<commit_message>
21:01 update AI table
</commit_message>
<xml_diff>
--- a/21_September_Monday/01_Seeking_for_AI/01_Seeking_for_AI.pptx
+++ b/21_September_Monday/01_Seeking_for_AI/01_Seeking_for_AI.pptx
@@ -78,7 +78,7 @@
           <a:p>
             <a:pPr algn="ctr"/>
             <a:r>
-              <a:rPr b="0" lang="fr-FR" sz="4400" strike="noStrike" u="none">
+              <a:rPr b="0" lang="en-US" sz="4400" strike="noStrike" u="none">
                 <a:solidFill>
                   <a:srgbClr val="000000"/>
                 </a:solidFill>
@@ -86,9 +86,9 @@
                 <a:uFillTx/>
                 <a:latin typeface="Arial"/>
               </a:rPr>
-              <a:t>Cliquez pour déplacer la diapo</a:t>
-            </a:r>
-            <a:endParaRPr b="0" lang="fr-FR" sz="4400" strike="noStrike" u="none">
+              <a:t>Click to move the slide</a:t>
+            </a:r>
+            <a:endParaRPr b="0" lang="en-US" sz="4400" strike="noStrike" u="none">
               <a:solidFill>
                 <a:srgbClr val="000000"/>
               </a:solidFill>
@@ -131,7 +131,7 @@
               <a:buNone/>
             </a:pPr>
             <a:r>
-              <a:rPr b="0" lang="fr-FR" sz="2000" strike="noStrike" u="none">
+              <a:rPr b="0" lang="en-US" sz="2000" strike="noStrike" u="none">
                 <a:solidFill>
                   <a:srgbClr val="000000"/>
                 </a:solidFill>
@@ -139,9 +139,9 @@
                 <a:uFillTx/>
                 <a:latin typeface="Arial"/>
               </a:rPr>
-              <a:t>Cliquez pour modifier le format des notes</a:t>
-            </a:r>
-            <a:endParaRPr b="0" lang="fr-FR" sz="2000" strike="noStrike" u="none">
+              <a:t>Click to edit the notes format</a:t>
+            </a:r>
+            <a:endParaRPr b="0" lang="en-US" sz="2000" strike="noStrike" u="none">
               <a:solidFill>
                 <a:srgbClr val="000000"/>
               </a:solidFill>
@@ -184,7 +184,7 @@
               <a:buNone/>
             </a:pPr>
             <a:r>
-              <a:rPr b="0" lang="fr-FR" sz="1400" strike="noStrike" u="none">
+              <a:rPr b="0" lang="en-US" sz="1400" strike="noStrike" u="none">
                 <a:solidFill>
                   <a:srgbClr val="000000"/>
                 </a:solidFill>
@@ -192,9 +192,9 @@
                 <a:uFillTx/>
                 <a:latin typeface="Times New Roman"/>
               </a:rPr>
-              <a:t>&lt;en-tête&gt;</a:t>
-            </a:r>
-            <a:endParaRPr b="0" lang="fr-FR" sz="1400" strike="noStrike" u="none">
+              <a:t>&lt;header&gt;</a:t>
+            </a:r>
+            <a:endParaRPr b="0" lang="en-US" sz="1400" strike="noStrike" u="none">
               <a:solidFill>
                 <a:srgbClr val="000000"/>
               </a:solidFill>
@@ -235,7 +235,7 @@
           <a:lstStyle>
             <a:lvl1pPr indent="0" algn="r">
               <a:buNone/>
-              <a:defRPr b="0" lang="fr-FR" sz="1400" strike="noStrike" u="none">
+              <a:defRPr b="0" lang="en-US" sz="1400" strike="noStrike" u="none">
                 <a:solidFill>
                   <a:srgbClr val="000000"/>
                 </a:solidFill>
@@ -250,7 +250,7 @@
               <a:buNone/>
             </a:pPr>
             <a:r>
-              <a:rPr b="0" lang="fr-FR" sz="1400" strike="noStrike" u="none">
+              <a:rPr b="0" lang="en-US" sz="1400" strike="noStrike" u="none">
                 <a:solidFill>
                   <a:srgbClr val="000000"/>
                 </a:solidFill>
@@ -258,9 +258,9 @@
                 <a:uFillTx/>
                 <a:latin typeface="Times New Roman"/>
               </a:rPr>
-              <a:t>&lt;date/heure&gt;</a:t>
-            </a:r>
-            <a:endParaRPr b="0" lang="fr-FR" sz="1400" strike="noStrike" u="none">
+              <a:t>&lt;date/time&gt;</a:t>
+            </a:r>
+            <a:endParaRPr b="0" lang="en-US" sz="1400" strike="noStrike" u="none">
               <a:solidFill>
                 <a:srgbClr val="000000"/>
               </a:solidFill>
@@ -301,7 +301,7 @@
           <a:lstStyle>
             <a:lvl1pPr indent="0">
               <a:buNone/>
-              <a:defRPr b="0" lang="fr-FR" sz="1400" strike="noStrike" u="none">
+              <a:defRPr b="0" lang="en-US" sz="1400" strike="noStrike" u="none">
                 <a:solidFill>
                   <a:srgbClr val="000000"/>
                 </a:solidFill>
@@ -316,7 +316,7 @@
               <a:buNone/>
             </a:pPr>
             <a:r>
-              <a:rPr b="0" lang="fr-FR" sz="1400" strike="noStrike" u="none">
+              <a:rPr b="0" lang="en-US" sz="1400" strike="noStrike" u="none">
                 <a:solidFill>
                   <a:srgbClr val="000000"/>
                 </a:solidFill>
@@ -324,9 +324,9 @@
                 <a:uFillTx/>
                 <a:latin typeface="Times New Roman"/>
               </a:rPr>
-              <a:t>&lt;pied de page&gt;</a:t>
-            </a:r>
-            <a:endParaRPr b="0" lang="fr-FR" sz="1400" strike="noStrike" u="none">
+              <a:t>&lt;footer&gt;</a:t>
+            </a:r>
+            <a:endParaRPr b="0" lang="en-US" sz="1400" strike="noStrike" u="none">
               <a:solidFill>
                 <a:srgbClr val="000000"/>
               </a:solidFill>
@@ -367,7 +367,7 @@
           <a:lstStyle>
             <a:lvl1pPr indent="0" algn="r">
               <a:buNone/>
-              <a:defRPr b="0" lang="fr-FR" sz="1400" strike="noStrike" u="none">
+              <a:defRPr b="0" lang="en-US" sz="1400" strike="noStrike" u="none">
                 <a:solidFill>
                   <a:srgbClr val="000000"/>
                 </a:solidFill>
@@ -381,8 +381,8 @@
             <a:pPr indent="0" algn="r">
               <a:buNone/>
             </a:pPr>
-            <a:fld id="{36A6B957-7FA4-4B37-AF94-8C0D0E2A218C}" type="slidenum">
-              <a:rPr b="0" lang="fr-FR" sz="1400" strike="noStrike" u="none">
+            <a:fld id="{FC9DB31D-555C-461F-9D45-BD8CD92D9C3E}" type="slidenum">
+              <a:rPr b="0" lang="en-US" sz="1400" strike="noStrike" u="none">
                 <a:solidFill>
                   <a:srgbClr val="000000"/>
                 </a:solidFill>
@@ -390,9 +390,9 @@
                 <a:uFillTx/>
                 <a:latin typeface="Times New Roman"/>
               </a:rPr>
-              <a:t>&lt;numéro&gt;</a:t>
+              <a:t>&lt;number&gt;</a:t>
             </a:fld>
-            <a:endParaRPr b="0" lang="fr-FR" sz="1400" strike="noStrike" u="none">
+            <a:endParaRPr b="0" lang="en-US" sz="1400" strike="noStrike" u="none">
               <a:solidFill>
                 <a:srgbClr val="000000"/>
               </a:solidFill>
@@ -428,7 +428,7 @@
       </p:grpSpPr>
       <p:sp>
         <p:nvSpPr>
-          <p:cNvPr id="124" name="PlaceHolder 1"/>
+          <p:cNvPr id="125" name="PlaceHolder 1"/>
           <p:cNvSpPr>
             <a:spLocks noGrp="1"/>
           </p:cNvSpPr>
@@ -451,7 +451,7 @@
       </p:sp>
       <p:sp>
         <p:nvSpPr>
-          <p:cNvPr id="125" name="PlaceHolder 2"/>
+          <p:cNvPr id="126" name="PlaceHolder 2"/>
           <p:cNvSpPr>
             <a:spLocks noGrp="1"/>
           </p:cNvSpPr>
@@ -480,7 +480,7 @@
             <a:pPr indent="0">
               <a:buNone/>
             </a:pPr>
-            <a:endParaRPr b="0" lang="fr-FR" sz="1800" strike="noStrike" u="none">
+            <a:endParaRPr b="0" lang="en-US" sz="1800" strike="noStrike" u="none">
               <a:solidFill>
                 <a:srgbClr val="000000"/>
               </a:solidFill>
@@ -493,7 +493,7 @@
       </p:sp>
       <p:sp>
         <p:nvSpPr>
-          <p:cNvPr id="126" name="PlaceHolder 3"/>
+          <p:cNvPr id="127" name="PlaceHolder 3"/>
           <p:cNvSpPr>
             <a:spLocks noGrp="1"/>
           </p:cNvSpPr>
@@ -548,7 +548,7 @@
                 <a:tab algn="l" pos="0"/>
               </a:tabLst>
             </a:pPr>
-            <a:fld id="{AD0744F6-99A8-455A-B74D-5916CC368BAD}" type="slidenum">
+            <a:fld id="{E744846D-4721-45EB-9655-55FCBE05A417}" type="slidenum">
               <a:rPr b="0" lang="en-US" sz="1800" strike="noStrike" u="none">
                 <a:solidFill>
                   <a:schemeClr val="dk1"/>
@@ -558,9 +558,9 @@
                 <a:latin typeface="+mn-lt"/>
                 <a:ea typeface="+mn-ea"/>
               </a:rPr>
-              <a:t>&lt;numéro&gt;</a:t>
+              <a:t>&lt;number&gt;</a:t>
             </a:fld>
-            <a:endParaRPr b="0" lang="fr-FR" sz="1800" strike="noStrike" u="none">
+            <a:endParaRPr b="0" lang="en-US" sz="1800" strike="noStrike" u="none">
               <a:solidFill>
                 <a:srgbClr val="000000"/>
               </a:solidFill>
@@ -595,7 +595,7 @@
       </p:grpSpPr>
       <p:sp>
         <p:nvSpPr>
-          <p:cNvPr id="148" name="PlaceHolder 1"/>
+          <p:cNvPr id="149" name="PlaceHolder 1"/>
           <p:cNvSpPr>
             <a:spLocks noGrp="1"/>
           </p:cNvSpPr>
@@ -618,7 +618,7 @@
       </p:sp>
       <p:sp>
         <p:nvSpPr>
-          <p:cNvPr id="149" name="PlaceHolder 2"/>
+          <p:cNvPr id="150" name="PlaceHolder 2"/>
           <p:cNvSpPr>
             <a:spLocks noGrp="1"/>
           </p:cNvSpPr>
@@ -647,7 +647,7 @@
             <a:pPr indent="0">
               <a:buNone/>
             </a:pPr>
-            <a:endParaRPr b="0" lang="fr-FR" sz="1800" strike="noStrike" u="none">
+            <a:endParaRPr b="0" lang="en-US" sz="1800" strike="noStrike" u="none">
               <a:solidFill>
                 <a:srgbClr val="000000"/>
               </a:solidFill>
@@ -660,7 +660,7 @@
       </p:sp>
       <p:sp>
         <p:nvSpPr>
-          <p:cNvPr id="150" name="PlaceHolder 3"/>
+          <p:cNvPr id="151" name="PlaceHolder 3"/>
           <p:cNvSpPr>
             <a:spLocks noGrp="1"/>
           </p:cNvSpPr>
@@ -715,7 +715,7 @@
                 <a:tab algn="l" pos="0"/>
               </a:tabLst>
             </a:pPr>
-            <a:fld id="{14C745CD-2591-40C7-A08C-011FCC347757}" type="slidenum">
+            <a:fld id="{1FB74336-82B5-4514-BAEC-E0A6EEFB0BDC}" type="slidenum">
               <a:rPr b="0" lang="en-US" sz="1800" strike="noStrike" u="none">
                 <a:solidFill>
                   <a:schemeClr val="dk1"/>
@@ -725,9 +725,9 @@
                 <a:latin typeface="+mn-lt"/>
                 <a:ea typeface="+mn-ea"/>
               </a:rPr>
-              <a:t>&lt;numéro&gt;</a:t>
+              <a:t>&lt;number&gt;</a:t>
             </a:fld>
-            <a:endParaRPr b="0" lang="fr-FR" sz="1800" strike="noStrike" u="none">
+            <a:endParaRPr b="0" lang="en-US" sz="1800" strike="noStrike" u="none">
               <a:solidFill>
                 <a:srgbClr val="000000"/>
               </a:solidFill>
@@ -762,7 +762,7 @@
       </p:grpSpPr>
       <p:sp>
         <p:nvSpPr>
-          <p:cNvPr id="151" name="PlaceHolder 1"/>
+          <p:cNvPr id="152" name="PlaceHolder 1"/>
           <p:cNvSpPr>
             <a:spLocks noGrp="1"/>
           </p:cNvSpPr>
@@ -785,7 +785,7 @@
       </p:sp>
       <p:sp>
         <p:nvSpPr>
-          <p:cNvPr id="152" name="PlaceHolder 2"/>
+          <p:cNvPr id="153" name="PlaceHolder 2"/>
           <p:cNvSpPr>
             <a:spLocks noGrp="1"/>
           </p:cNvSpPr>
@@ -814,7 +814,7 @@
             <a:pPr indent="0">
               <a:buNone/>
             </a:pPr>
-            <a:endParaRPr b="0" lang="fr-FR" sz="1800" strike="noStrike" u="none">
+            <a:endParaRPr b="0" lang="en-US" sz="1800" strike="noStrike" u="none">
               <a:solidFill>
                 <a:srgbClr val="000000"/>
               </a:solidFill>
@@ -827,7 +827,7 @@
       </p:sp>
       <p:sp>
         <p:nvSpPr>
-          <p:cNvPr id="153" name="PlaceHolder 3"/>
+          <p:cNvPr id="154" name="PlaceHolder 3"/>
           <p:cNvSpPr>
             <a:spLocks noGrp="1"/>
           </p:cNvSpPr>
@@ -882,7 +882,7 @@
                 <a:tab algn="l" pos="0"/>
               </a:tabLst>
             </a:pPr>
-            <a:fld id="{A4168247-6272-4E14-AD51-4092B572EE20}" type="slidenum">
+            <a:fld id="{8438EBB0-F383-424E-97BC-D47039784867}" type="slidenum">
               <a:rPr b="0" lang="en-US" sz="1800" strike="noStrike" u="none">
                 <a:solidFill>
                   <a:schemeClr val="dk1"/>
@@ -892,9 +892,9 @@
                 <a:latin typeface="+mn-lt"/>
                 <a:ea typeface="+mn-ea"/>
               </a:rPr>
-              <a:t>&lt;numéro&gt;</a:t>
+              <a:t>&lt;number&gt;</a:t>
             </a:fld>
-            <a:endParaRPr b="0" lang="fr-FR" sz="1800" strike="noStrike" u="none">
+            <a:endParaRPr b="0" lang="en-US" sz="1800" strike="noStrike" u="none">
               <a:solidFill>
                 <a:srgbClr val="000000"/>
               </a:solidFill>
@@ -929,7 +929,7 @@
       </p:grpSpPr>
       <p:sp>
         <p:nvSpPr>
-          <p:cNvPr id="127" name="PlaceHolder 1"/>
+          <p:cNvPr id="128" name="PlaceHolder 1"/>
           <p:cNvSpPr>
             <a:spLocks noGrp="1"/>
           </p:cNvSpPr>
@@ -952,7 +952,7 @@
       </p:sp>
       <p:sp>
         <p:nvSpPr>
-          <p:cNvPr id="128" name="PlaceHolder 2"/>
+          <p:cNvPr id="129" name="PlaceHolder 2"/>
           <p:cNvSpPr>
             <a:spLocks noGrp="1"/>
           </p:cNvSpPr>
@@ -981,7 +981,7 @@
             <a:pPr indent="0">
               <a:buNone/>
             </a:pPr>
-            <a:endParaRPr b="0" lang="fr-FR" sz="1800" strike="noStrike" u="none">
+            <a:endParaRPr b="0" lang="en-US" sz="1800" strike="noStrike" u="none">
               <a:solidFill>
                 <a:srgbClr val="000000"/>
               </a:solidFill>
@@ -994,7 +994,7 @@
       </p:sp>
       <p:sp>
         <p:nvSpPr>
-          <p:cNvPr id="129" name="PlaceHolder 3"/>
+          <p:cNvPr id="130" name="PlaceHolder 3"/>
           <p:cNvSpPr>
             <a:spLocks noGrp="1"/>
           </p:cNvSpPr>
@@ -1049,7 +1049,7 @@
                 <a:tab algn="l" pos="0"/>
               </a:tabLst>
             </a:pPr>
-            <a:fld id="{392C4F97-A299-416D-849B-E8A6D6342965}" type="slidenum">
+            <a:fld id="{99EFD446-17B7-4AB1-8022-B7D77CFBE562}" type="slidenum">
               <a:rPr b="0" lang="en-US" sz="1800" strike="noStrike" u="none">
                 <a:solidFill>
                   <a:schemeClr val="dk1"/>
@@ -1059,9 +1059,9 @@
                 <a:latin typeface="+mn-lt"/>
                 <a:ea typeface="+mn-ea"/>
               </a:rPr>
-              <a:t>&lt;numéro&gt;</a:t>
+              <a:t>&lt;number&gt;</a:t>
             </a:fld>
-            <a:endParaRPr b="0" lang="fr-FR" sz="1800" strike="noStrike" u="none">
+            <a:endParaRPr b="0" lang="en-US" sz="1800" strike="noStrike" u="none">
               <a:solidFill>
                 <a:srgbClr val="000000"/>
               </a:solidFill>
@@ -1096,7 +1096,7 @@
       </p:grpSpPr>
       <p:sp>
         <p:nvSpPr>
-          <p:cNvPr id="130" name="PlaceHolder 1"/>
+          <p:cNvPr id="131" name="PlaceHolder 1"/>
           <p:cNvSpPr>
             <a:spLocks noGrp="1"/>
           </p:cNvSpPr>
@@ -1119,7 +1119,7 @@
       </p:sp>
       <p:sp>
         <p:nvSpPr>
-          <p:cNvPr id="131" name="PlaceHolder 2"/>
+          <p:cNvPr id="132" name="PlaceHolder 2"/>
           <p:cNvSpPr>
             <a:spLocks noGrp="1"/>
           </p:cNvSpPr>
@@ -1148,7 +1148,7 @@
             <a:pPr indent="0">
               <a:buNone/>
             </a:pPr>
-            <a:endParaRPr b="0" lang="fr-FR" sz="1800" strike="noStrike" u="none">
+            <a:endParaRPr b="0" lang="en-US" sz="1800" strike="noStrike" u="none">
               <a:solidFill>
                 <a:srgbClr val="000000"/>
               </a:solidFill>
@@ -1161,7 +1161,7 @@
       </p:sp>
       <p:sp>
         <p:nvSpPr>
-          <p:cNvPr id="132" name="PlaceHolder 3"/>
+          <p:cNvPr id="133" name="PlaceHolder 3"/>
           <p:cNvSpPr>
             <a:spLocks noGrp="1"/>
           </p:cNvSpPr>
@@ -1216,7 +1216,7 @@
                 <a:tab algn="l" pos="0"/>
               </a:tabLst>
             </a:pPr>
-            <a:fld id="{4C363B45-95F7-497D-9430-C451829F28F7}" type="slidenum">
+            <a:fld id="{28552152-D44F-47BA-B541-F5CAB0A732FD}" type="slidenum">
               <a:rPr b="0" lang="en-US" sz="1800" strike="noStrike" u="none">
                 <a:solidFill>
                   <a:schemeClr val="dk1"/>
@@ -1226,9 +1226,9 @@
                 <a:latin typeface="+mn-lt"/>
                 <a:ea typeface="+mn-ea"/>
               </a:rPr>
-              <a:t>&lt;numéro&gt;</a:t>
+              <a:t>&lt;number&gt;</a:t>
             </a:fld>
-            <a:endParaRPr b="0" lang="fr-FR" sz="1800" strike="noStrike" u="none">
+            <a:endParaRPr b="0" lang="en-US" sz="1800" strike="noStrike" u="none">
               <a:solidFill>
                 <a:srgbClr val="000000"/>
               </a:solidFill>
@@ -1263,7 +1263,7 @@
       </p:grpSpPr>
       <p:sp>
         <p:nvSpPr>
-          <p:cNvPr id="133" name="PlaceHolder 1"/>
+          <p:cNvPr id="134" name="PlaceHolder 1"/>
           <p:cNvSpPr>
             <a:spLocks noGrp="1"/>
           </p:cNvSpPr>
@@ -1286,7 +1286,7 @@
       </p:sp>
       <p:sp>
         <p:nvSpPr>
-          <p:cNvPr id="134" name="PlaceHolder 2"/>
+          <p:cNvPr id="135" name="PlaceHolder 2"/>
           <p:cNvSpPr>
             <a:spLocks noGrp="1"/>
           </p:cNvSpPr>
@@ -1315,7 +1315,7 @@
             <a:pPr indent="0">
               <a:buNone/>
             </a:pPr>
-            <a:endParaRPr b="0" lang="fr-FR" sz="1800" strike="noStrike" u="none">
+            <a:endParaRPr b="0" lang="en-US" sz="1800" strike="noStrike" u="none">
               <a:solidFill>
                 <a:srgbClr val="000000"/>
               </a:solidFill>
@@ -1328,7 +1328,7 @@
       </p:sp>
       <p:sp>
         <p:nvSpPr>
-          <p:cNvPr id="135" name="PlaceHolder 3"/>
+          <p:cNvPr id="136" name="PlaceHolder 3"/>
           <p:cNvSpPr>
             <a:spLocks noGrp="1"/>
           </p:cNvSpPr>
@@ -1383,7 +1383,7 @@
                 <a:tab algn="l" pos="0"/>
               </a:tabLst>
             </a:pPr>
-            <a:fld id="{92834131-A786-4D1F-AD60-18D46722D9A6}" type="slidenum">
+            <a:fld id="{A95A3325-13DF-40E7-8919-AC163F616BBE}" type="slidenum">
               <a:rPr b="0" lang="en-US" sz="1800" strike="noStrike" u="none">
                 <a:solidFill>
                   <a:schemeClr val="dk1"/>
@@ -1393,9 +1393,9 @@
                 <a:latin typeface="+mn-lt"/>
                 <a:ea typeface="+mn-ea"/>
               </a:rPr>
-              <a:t>&lt;numéro&gt;</a:t>
+              <a:t>&lt;number&gt;</a:t>
             </a:fld>
-            <a:endParaRPr b="0" lang="fr-FR" sz="1800" strike="noStrike" u="none">
+            <a:endParaRPr b="0" lang="en-US" sz="1800" strike="noStrike" u="none">
               <a:solidFill>
                 <a:srgbClr val="000000"/>
               </a:solidFill>
@@ -1430,7 +1430,7 @@
       </p:grpSpPr>
       <p:sp>
         <p:nvSpPr>
-          <p:cNvPr id="136" name="PlaceHolder 1"/>
+          <p:cNvPr id="137" name="PlaceHolder 1"/>
           <p:cNvSpPr>
             <a:spLocks noGrp="1"/>
           </p:cNvSpPr>
@@ -1453,7 +1453,7 @@
       </p:sp>
       <p:sp>
         <p:nvSpPr>
-          <p:cNvPr id="137" name="PlaceHolder 2"/>
+          <p:cNvPr id="138" name="PlaceHolder 2"/>
           <p:cNvSpPr>
             <a:spLocks noGrp="1"/>
           </p:cNvSpPr>
@@ -1482,7 +1482,7 @@
             <a:pPr indent="0">
               <a:buNone/>
             </a:pPr>
-            <a:endParaRPr b="0" lang="fr-FR" sz="1800" strike="noStrike" u="none">
+            <a:endParaRPr b="0" lang="en-US" sz="1800" strike="noStrike" u="none">
               <a:solidFill>
                 <a:srgbClr val="000000"/>
               </a:solidFill>
@@ -1495,7 +1495,7 @@
       </p:sp>
       <p:sp>
         <p:nvSpPr>
-          <p:cNvPr id="138" name="PlaceHolder 3"/>
+          <p:cNvPr id="139" name="PlaceHolder 3"/>
           <p:cNvSpPr>
             <a:spLocks noGrp="1"/>
           </p:cNvSpPr>
@@ -1550,7 +1550,7 @@
                 <a:tab algn="l" pos="0"/>
               </a:tabLst>
             </a:pPr>
-            <a:fld id="{F1F391A1-C91F-4029-B3F9-0A0FC139E963}" type="slidenum">
+            <a:fld id="{7A001CBD-1396-4E51-815B-E4B38D381888}" type="slidenum">
               <a:rPr b="0" lang="en-US" sz="1800" strike="noStrike" u="none">
                 <a:solidFill>
                   <a:schemeClr val="dk1"/>
@@ -1560,9 +1560,9 @@
                 <a:latin typeface="+mn-lt"/>
                 <a:ea typeface="+mn-ea"/>
               </a:rPr>
-              <a:t>&lt;numéro&gt;</a:t>
+              <a:t>&lt;number&gt;</a:t>
             </a:fld>
-            <a:endParaRPr b="0" lang="fr-FR" sz="1800" strike="noStrike" u="none">
+            <a:endParaRPr b="0" lang="en-US" sz="1800" strike="noStrike" u="none">
               <a:solidFill>
                 <a:srgbClr val="000000"/>
               </a:solidFill>
@@ -1597,7 +1597,7 @@
       </p:grpSpPr>
       <p:sp>
         <p:nvSpPr>
-          <p:cNvPr id="139" name="PlaceHolder 1"/>
+          <p:cNvPr id="140" name="PlaceHolder 1"/>
           <p:cNvSpPr>
             <a:spLocks noGrp="1"/>
           </p:cNvSpPr>
@@ -1620,7 +1620,7 @@
       </p:sp>
       <p:sp>
         <p:nvSpPr>
-          <p:cNvPr id="140" name="PlaceHolder 2"/>
+          <p:cNvPr id="141" name="PlaceHolder 2"/>
           <p:cNvSpPr>
             <a:spLocks noGrp="1"/>
           </p:cNvSpPr>
@@ -1649,7 +1649,7 @@
             <a:pPr indent="0">
               <a:buNone/>
             </a:pPr>
-            <a:endParaRPr b="0" lang="fr-FR" sz="1800" strike="noStrike" u="none">
+            <a:endParaRPr b="0" lang="en-US" sz="1800" strike="noStrike" u="none">
               <a:solidFill>
                 <a:srgbClr val="000000"/>
               </a:solidFill>
@@ -1662,7 +1662,7 @@
       </p:sp>
       <p:sp>
         <p:nvSpPr>
-          <p:cNvPr id="141" name="PlaceHolder 3"/>
+          <p:cNvPr id="142" name="PlaceHolder 3"/>
           <p:cNvSpPr>
             <a:spLocks noGrp="1"/>
           </p:cNvSpPr>
@@ -1717,7 +1717,7 @@
                 <a:tab algn="l" pos="0"/>
               </a:tabLst>
             </a:pPr>
-            <a:fld id="{1F584802-63CD-4F18-A4D0-C5FF4B4ED0BB}" type="slidenum">
+            <a:fld id="{C077B06D-2306-49B8-9E60-475C1CD6C2D5}" type="slidenum">
               <a:rPr b="0" lang="en-US" sz="1800" strike="noStrike" u="none">
                 <a:solidFill>
                   <a:schemeClr val="dk1"/>
@@ -1727,9 +1727,9 @@
                 <a:latin typeface="+mn-lt"/>
                 <a:ea typeface="+mn-ea"/>
               </a:rPr>
-              <a:t>&lt;numéro&gt;</a:t>
+              <a:t>&lt;number&gt;</a:t>
             </a:fld>
-            <a:endParaRPr b="0" lang="fr-FR" sz="1800" strike="noStrike" u="none">
+            <a:endParaRPr b="0" lang="en-US" sz="1800" strike="noStrike" u="none">
               <a:solidFill>
                 <a:srgbClr val="000000"/>
               </a:solidFill>
@@ -1764,7 +1764,7 @@
       </p:grpSpPr>
       <p:sp>
         <p:nvSpPr>
-          <p:cNvPr id="142" name="PlaceHolder 1"/>
+          <p:cNvPr id="143" name="PlaceHolder 1"/>
           <p:cNvSpPr>
             <a:spLocks noGrp="1"/>
           </p:cNvSpPr>
@@ -1787,7 +1787,7 @@
       </p:sp>
       <p:sp>
         <p:nvSpPr>
-          <p:cNvPr id="143" name="PlaceHolder 2"/>
+          <p:cNvPr id="144" name="PlaceHolder 2"/>
           <p:cNvSpPr>
             <a:spLocks noGrp="1"/>
           </p:cNvSpPr>
@@ -1816,7 +1816,7 @@
             <a:pPr indent="0">
               <a:buNone/>
             </a:pPr>
-            <a:endParaRPr b="0" lang="fr-FR" sz="1800" strike="noStrike" u="none">
+            <a:endParaRPr b="0" lang="en-US" sz="1800" strike="noStrike" u="none">
               <a:solidFill>
                 <a:srgbClr val="000000"/>
               </a:solidFill>
@@ -1829,7 +1829,7 @@
       </p:sp>
       <p:sp>
         <p:nvSpPr>
-          <p:cNvPr id="144" name="PlaceHolder 3"/>
+          <p:cNvPr id="145" name="PlaceHolder 3"/>
           <p:cNvSpPr>
             <a:spLocks noGrp="1"/>
           </p:cNvSpPr>
@@ -1884,7 +1884,7 @@
                 <a:tab algn="l" pos="0"/>
               </a:tabLst>
             </a:pPr>
-            <a:fld id="{8558122D-F703-449A-A8A8-1C6C535E70A0}" type="slidenum">
+            <a:fld id="{43255A38-9385-41AA-89C6-6AFB0540D153}" type="slidenum">
               <a:rPr b="0" lang="en-US" sz="1800" strike="noStrike" u="none">
                 <a:solidFill>
                   <a:schemeClr val="dk1"/>
@@ -1894,9 +1894,9 @@
                 <a:latin typeface="+mn-lt"/>
                 <a:ea typeface="+mn-ea"/>
               </a:rPr>
-              <a:t>&lt;numéro&gt;</a:t>
+              <a:t>&lt;number&gt;</a:t>
             </a:fld>
-            <a:endParaRPr b="0" lang="fr-FR" sz="1800" strike="noStrike" u="none">
+            <a:endParaRPr b="0" lang="en-US" sz="1800" strike="noStrike" u="none">
               <a:solidFill>
                 <a:srgbClr val="000000"/>
               </a:solidFill>
@@ -1931,7 +1931,7 @@
       </p:grpSpPr>
       <p:sp>
         <p:nvSpPr>
-          <p:cNvPr id="145" name="PlaceHolder 1"/>
+          <p:cNvPr id="146" name="PlaceHolder 1"/>
           <p:cNvSpPr>
             <a:spLocks noGrp="1"/>
           </p:cNvSpPr>
@@ -1954,7 +1954,7 @@
       </p:sp>
       <p:sp>
         <p:nvSpPr>
-          <p:cNvPr id="146" name="PlaceHolder 2"/>
+          <p:cNvPr id="147" name="PlaceHolder 2"/>
           <p:cNvSpPr>
             <a:spLocks noGrp="1"/>
           </p:cNvSpPr>
@@ -1983,7 +1983,7 @@
             <a:pPr indent="0">
               <a:buNone/>
             </a:pPr>
-            <a:endParaRPr b="0" lang="fr-FR" sz="1800" strike="noStrike" u="none">
+            <a:endParaRPr b="0" lang="en-US" sz="1800" strike="noStrike" u="none">
               <a:solidFill>
                 <a:srgbClr val="000000"/>
               </a:solidFill>
@@ -1996,7 +1996,7 @@
       </p:sp>
       <p:sp>
         <p:nvSpPr>
-          <p:cNvPr id="147" name="PlaceHolder 3"/>
+          <p:cNvPr id="148" name="PlaceHolder 3"/>
           <p:cNvSpPr>
             <a:spLocks noGrp="1"/>
           </p:cNvSpPr>
@@ -2051,7 +2051,7 @@
                 <a:tab algn="l" pos="0"/>
               </a:tabLst>
             </a:pPr>
-            <a:fld id="{AC96F2DC-E5DC-4CCB-8F09-E5AA3CD442F2}" type="slidenum">
+            <a:fld id="{F0B194AB-85C3-40F2-8E87-F63BF88099E2}" type="slidenum">
               <a:rPr b="0" lang="en-US" sz="1800" strike="noStrike" u="none">
                 <a:solidFill>
                   <a:schemeClr val="dk1"/>
@@ -2061,9 +2061,9 @@
                 <a:latin typeface="+mn-lt"/>
                 <a:ea typeface="+mn-ea"/>
               </a:rPr>
-              <a:t>&lt;numéro&gt;</a:t>
+              <a:t>&lt;number&gt;</a:t>
             </a:fld>
-            <a:endParaRPr b="0" lang="fr-FR" sz="1800" strike="noStrike" u="none">
+            <a:endParaRPr b="0" lang="en-US" sz="1800" strike="noStrike" u="none">
               <a:solidFill>
                 <a:srgbClr val="000000"/>
               </a:solidFill>
@@ -2112,7 +2112,7 @@
         <p:spPr>
           <a:xfrm>
             <a:off x="548640" y="6446880"/>
-            <a:ext cx="6398640" cy="272160"/>
+            <a:ext cx="6398280" cy="271800"/>
           </a:xfrm>
           <a:prstGeom prst="rect">
             <a:avLst/>
@@ -2153,7 +2153,7 @@
               </a:rPr>
               <a:t>Seeking for AI</a:t>
             </a:r>
-            <a:endParaRPr b="0" lang="fr-FR" sz="900" strike="noStrike" u="none">
+            <a:endParaRPr b="0" lang="en-US" sz="900" strike="noStrike" u="none">
               <a:solidFill>
                 <a:srgbClr val="000000"/>
               </a:solidFill>
@@ -2173,7 +2173,7 @@
         <p:spPr>
           <a:xfrm>
             <a:off x="11185920" y="6446880"/>
-            <a:ext cx="455040" cy="272160"/>
+            <a:ext cx="454680" cy="271800"/>
           </a:xfrm>
           <a:prstGeom prst="rect">
             <a:avLst/>
@@ -2214,7 +2214,7 @@
               </a:rPr>
               <a:t>2</a:t>
             </a:r>
-            <a:endParaRPr b="0" lang="fr-FR" sz="900" strike="noStrike" u="none">
+            <a:endParaRPr b="0" lang="en-US" sz="900" strike="noStrike" u="none">
               <a:solidFill>
                 <a:srgbClr val="000000"/>
               </a:solidFill>
@@ -2239,7 +2239,7 @@
         <p:spPr>
           <a:xfrm>
             <a:off x="10375920" y="356040"/>
-            <a:ext cx="1267920" cy="649440"/>
+            <a:ext cx="1267560" cy="649080"/>
           </a:xfrm>
           <a:prstGeom prst="rect">
             <a:avLst/>
@@ -2263,7 +2263,7 @@
         <p:spPr>
           <a:xfrm>
             <a:off x="609480" y="273600"/>
-            <a:ext cx="10971360" cy="1143720"/>
+            <a:ext cx="10971000" cy="1143360"/>
           </a:xfrm>
           <a:prstGeom prst="rect">
             <a:avLst/>
@@ -2298,7 +2298,7 @@
               </a:rPr>
               <a:t>Click to edit the title text format</a:t>
             </a:r>
-            <a:endParaRPr b="0" lang="fr-FR" sz="4400" strike="noStrike" u="none">
+            <a:endParaRPr b="0" lang="en-US" sz="4400" strike="noStrike" u="none">
               <a:solidFill>
                 <a:srgbClr val="000000"/>
               </a:solidFill>
@@ -2322,7 +2322,7 @@
         <p:spPr>
           <a:xfrm>
             <a:off x="609480" y="1604520"/>
-            <a:ext cx="10971360" cy="3976200"/>
+            <a:ext cx="10971000" cy="3975840"/>
           </a:xfrm>
           <a:prstGeom prst="rect">
             <a:avLst/>
@@ -2362,7 +2362,7 @@
               </a:rPr>
               <a:t>Click to edit the outline text format</a:t>
             </a:r>
-            <a:endParaRPr b="0" lang="fr-FR" sz="3200" strike="noStrike" u="none">
+            <a:endParaRPr b="0" lang="en-US" sz="3200" strike="noStrike" u="none">
               <a:solidFill>
                 <a:srgbClr val="000000"/>
               </a:solidFill>
@@ -2397,7 +2397,7 @@
               </a:rPr>
               <a:t>Second Outline Level</a:t>
             </a:r>
-            <a:endParaRPr b="0" lang="fr-FR" sz="2800" strike="noStrike" u="none">
+            <a:endParaRPr b="0" lang="en-US" sz="2800" strike="noStrike" u="none">
               <a:solidFill>
                 <a:srgbClr val="000000"/>
               </a:solidFill>
@@ -2432,7 +2432,7 @@
               </a:rPr>
               <a:t>Third Outline Level</a:t>
             </a:r>
-            <a:endParaRPr b="0" lang="fr-FR" sz="2400" strike="noStrike" u="none">
+            <a:endParaRPr b="0" lang="en-US" sz="2400" strike="noStrike" u="none">
               <a:solidFill>
                 <a:srgbClr val="000000"/>
               </a:solidFill>
@@ -2467,7 +2467,7 @@
               </a:rPr>
               <a:t>Fourth Outline Level</a:t>
             </a:r>
-            <a:endParaRPr b="0" lang="fr-FR" sz="2000" strike="noStrike" u="none">
+            <a:endParaRPr b="0" lang="en-US" sz="2000" strike="noStrike" u="none">
               <a:solidFill>
                 <a:srgbClr val="000000"/>
               </a:solidFill>
@@ -2502,7 +2502,7 @@
               </a:rPr>
               <a:t>Fifth Outline Level</a:t>
             </a:r>
-            <a:endParaRPr b="0" lang="fr-FR" sz="2000" strike="noStrike" u="none">
+            <a:endParaRPr b="0" lang="en-US" sz="2000" strike="noStrike" u="none">
               <a:solidFill>
                 <a:srgbClr val="000000"/>
               </a:solidFill>
@@ -2537,7 +2537,7 @@
               </a:rPr>
               <a:t>Sixth Outline Level</a:t>
             </a:r>
-            <a:endParaRPr b="0" lang="fr-FR" sz="2000" strike="noStrike" u="none">
+            <a:endParaRPr b="0" lang="en-US" sz="2000" strike="noStrike" u="none">
               <a:solidFill>
                 <a:srgbClr val="000000"/>
               </a:solidFill>
@@ -2572,7 +2572,7 @@
               </a:rPr>
               <a:t>Seventh Outline Level</a:t>
             </a:r>
-            <a:endParaRPr b="0" lang="fr-FR" sz="2000" strike="noStrike" u="none">
+            <a:endParaRPr b="0" lang="en-US" sz="2000" strike="noStrike" u="none">
               <a:solidFill>
                 <a:srgbClr val="000000"/>
               </a:solidFill>
@@ -2621,7 +2621,7 @@
         <p:spPr>
           <a:xfrm>
             <a:off x="548640" y="6446880"/>
-            <a:ext cx="6398640" cy="272160"/>
+            <a:ext cx="6398280" cy="271800"/>
           </a:xfrm>
           <a:prstGeom prst="rect">
             <a:avLst/>
@@ -2662,7 +2662,7 @@
               </a:rPr>
               <a:t>Seeking for AI</a:t>
             </a:r>
-            <a:endParaRPr b="0" lang="fr-FR" sz="900" strike="noStrike" u="none">
+            <a:endParaRPr b="0" lang="en-US" sz="900" strike="noStrike" u="none">
               <a:solidFill>
                 <a:srgbClr val="000000"/>
               </a:solidFill>
@@ -2682,7 +2682,7 @@
         <p:spPr>
           <a:xfrm>
             <a:off x="11185920" y="6446880"/>
-            <a:ext cx="455040" cy="272160"/>
+            <a:ext cx="454680" cy="271800"/>
           </a:xfrm>
           <a:prstGeom prst="rect">
             <a:avLst/>
@@ -2723,7 +2723,7 @@
               </a:rPr>
               <a:t>2</a:t>
             </a:r>
-            <a:endParaRPr b="0" lang="fr-FR" sz="900" strike="noStrike" u="none">
+            <a:endParaRPr b="0" lang="en-US" sz="900" strike="noStrike" u="none">
               <a:solidFill>
                 <a:srgbClr val="000000"/>
               </a:solidFill>
@@ -2748,7 +2748,7 @@
         <p:spPr>
           <a:xfrm>
             <a:off x="10375920" y="356040"/>
-            <a:ext cx="1267920" cy="649440"/>
+            <a:ext cx="1267560" cy="649080"/>
           </a:xfrm>
           <a:prstGeom prst="rect">
             <a:avLst/>
@@ -2772,7 +2772,7 @@
         <p:spPr>
           <a:xfrm>
             <a:off x="609480" y="273600"/>
-            <a:ext cx="10971360" cy="1143720"/>
+            <a:ext cx="10971000" cy="1143360"/>
           </a:xfrm>
           <a:prstGeom prst="rect">
             <a:avLst/>
@@ -2807,7 +2807,7 @@
               </a:rPr>
               <a:t>Click to edit the title text format</a:t>
             </a:r>
-            <a:endParaRPr b="0" lang="fr-FR" sz="4400" strike="noStrike" u="none">
+            <a:endParaRPr b="0" lang="en-US" sz="4400" strike="noStrike" u="none">
               <a:solidFill>
                 <a:srgbClr val="000000"/>
               </a:solidFill>
@@ -2831,7 +2831,7 @@
         <p:spPr>
           <a:xfrm>
             <a:off x="609480" y="1604520"/>
-            <a:ext cx="10971360" cy="3976200"/>
+            <a:ext cx="10971000" cy="3975840"/>
           </a:xfrm>
           <a:prstGeom prst="rect">
             <a:avLst/>
@@ -2871,7 +2871,7 @@
               </a:rPr>
               <a:t>Click to edit the outline text format</a:t>
             </a:r>
-            <a:endParaRPr b="0" lang="fr-FR" sz="3200" strike="noStrike" u="none">
+            <a:endParaRPr b="0" lang="en-US" sz="3200" strike="noStrike" u="none">
               <a:solidFill>
                 <a:srgbClr val="000000"/>
               </a:solidFill>
@@ -2906,7 +2906,7 @@
               </a:rPr>
               <a:t>Second Outline Level</a:t>
             </a:r>
-            <a:endParaRPr b="0" lang="fr-FR" sz="2800" strike="noStrike" u="none">
+            <a:endParaRPr b="0" lang="en-US" sz="2800" strike="noStrike" u="none">
               <a:solidFill>
                 <a:srgbClr val="000000"/>
               </a:solidFill>
@@ -2941,7 +2941,7 @@
               </a:rPr>
               <a:t>Third Outline Level</a:t>
             </a:r>
-            <a:endParaRPr b="0" lang="fr-FR" sz="2400" strike="noStrike" u="none">
+            <a:endParaRPr b="0" lang="en-US" sz="2400" strike="noStrike" u="none">
               <a:solidFill>
                 <a:srgbClr val="000000"/>
               </a:solidFill>
@@ -2976,7 +2976,7 @@
               </a:rPr>
               <a:t>Fourth Outline Level</a:t>
             </a:r>
-            <a:endParaRPr b="0" lang="fr-FR" sz="2000" strike="noStrike" u="none">
+            <a:endParaRPr b="0" lang="en-US" sz="2000" strike="noStrike" u="none">
               <a:solidFill>
                 <a:srgbClr val="000000"/>
               </a:solidFill>
@@ -3011,7 +3011,7 @@
               </a:rPr>
               <a:t>Fifth Outline Level</a:t>
             </a:r>
-            <a:endParaRPr b="0" lang="fr-FR" sz="2000" strike="noStrike" u="none">
+            <a:endParaRPr b="0" lang="en-US" sz="2000" strike="noStrike" u="none">
               <a:solidFill>
                 <a:srgbClr val="000000"/>
               </a:solidFill>
@@ -3046,7 +3046,7 @@
               </a:rPr>
               <a:t>Sixth Outline Level</a:t>
             </a:r>
-            <a:endParaRPr b="0" lang="fr-FR" sz="2000" strike="noStrike" u="none">
+            <a:endParaRPr b="0" lang="en-US" sz="2000" strike="noStrike" u="none">
               <a:solidFill>
                 <a:srgbClr val="000000"/>
               </a:solidFill>
@@ -3081,7 +3081,7 @@
               </a:rPr>
               <a:t>Seventh Outline Level</a:t>
             </a:r>
-            <a:endParaRPr b="0" lang="fr-FR" sz="2000" strike="noStrike" u="none">
+            <a:endParaRPr b="0" lang="en-US" sz="2000" strike="noStrike" u="none">
               <a:solidFill>
                 <a:srgbClr val="000000"/>
               </a:solidFill>
@@ -3130,7 +3130,7 @@
         <p:spPr>
           <a:xfrm>
             <a:off x="548640" y="6446880"/>
-            <a:ext cx="6398640" cy="272160"/>
+            <a:ext cx="6398280" cy="271800"/>
           </a:xfrm>
           <a:prstGeom prst="rect">
             <a:avLst/>
@@ -3171,7 +3171,7 @@
               </a:rPr>
               <a:t>Seeking for AI</a:t>
             </a:r>
-            <a:endParaRPr b="0" lang="fr-FR" sz="900" strike="noStrike" u="none">
+            <a:endParaRPr b="0" lang="en-US" sz="900" strike="noStrike" u="none">
               <a:solidFill>
                 <a:srgbClr val="000000"/>
               </a:solidFill>
@@ -3191,7 +3191,7 @@
         <p:spPr>
           <a:xfrm>
             <a:off x="11185920" y="6446880"/>
-            <a:ext cx="455040" cy="272160"/>
+            <a:ext cx="454680" cy="271800"/>
           </a:xfrm>
           <a:prstGeom prst="rect">
             <a:avLst/>
@@ -3232,7 +3232,7 @@
               </a:rPr>
               <a:t>2</a:t>
             </a:r>
-            <a:endParaRPr b="0" lang="fr-FR" sz="900" strike="noStrike" u="none">
+            <a:endParaRPr b="0" lang="en-US" sz="900" strike="noStrike" u="none">
               <a:solidFill>
                 <a:srgbClr val="000000"/>
               </a:solidFill>
@@ -3257,7 +3257,7 @@
         <p:spPr>
           <a:xfrm>
             <a:off x="10375920" y="356040"/>
-            <a:ext cx="1267920" cy="649440"/>
+            <a:ext cx="1267560" cy="649080"/>
           </a:xfrm>
           <a:prstGeom prst="rect">
             <a:avLst/>
@@ -3281,7 +3281,7 @@
         <p:spPr>
           <a:xfrm>
             <a:off x="609480" y="273600"/>
-            <a:ext cx="10971360" cy="1143720"/>
+            <a:ext cx="10971000" cy="1143360"/>
           </a:xfrm>
           <a:prstGeom prst="rect">
             <a:avLst/>
@@ -3316,7 +3316,7 @@
               </a:rPr>
               <a:t>Click to edit the title text format</a:t>
             </a:r>
-            <a:endParaRPr b="0" lang="fr-FR" sz="4400" strike="noStrike" u="none">
+            <a:endParaRPr b="0" lang="en-US" sz="4400" strike="noStrike" u="none">
               <a:solidFill>
                 <a:srgbClr val="000000"/>
               </a:solidFill>
@@ -3340,7 +3340,7 @@
         <p:spPr>
           <a:xfrm>
             <a:off x="609480" y="1604520"/>
-            <a:ext cx="10971360" cy="3976200"/>
+            <a:ext cx="10971000" cy="3975840"/>
           </a:xfrm>
           <a:prstGeom prst="rect">
             <a:avLst/>
@@ -3380,7 +3380,7 @@
               </a:rPr>
               <a:t>Click to edit the outline text format</a:t>
             </a:r>
-            <a:endParaRPr b="0" lang="fr-FR" sz="3200" strike="noStrike" u="none">
+            <a:endParaRPr b="0" lang="en-US" sz="3200" strike="noStrike" u="none">
               <a:solidFill>
                 <a:srgbClr val="000000"/>
               </a:solidFill>
@@ -3415,7 +3415,7 @@
               </a:rPr>
               <a:t>Second Outline Level</a:t>
             </a:r>
-            <a:endParaRPr b="0" lang="fr-FR" sz="2800" strike="noStrike" u="none">
+            <a:endParaRPr b="0" lang="en-US" sz="2800" strike="noStrike" u="none">
               <a:solidFill>
                 <a:srgbClr val="000000"/>
               </a:solidFill>
@@ -3450,7 +3450,7 @@
               </a:rPr>
               <a:t>Third Outline Level</a:t>
             </a:r>
-            <a:endParaRPr b="0" lang="fr-FR" sz="2400" strike="noStrike" u="none">
+            <a:endParaRPr b="0" lang="en-US" sz="2400" strike="noStrike" u="none">
               <a:solidFill>
                 <a:srgbClr val="000000"/>
               </a:solidFill>
@@ -3485,7 +3485,7 @@
               </a:rPr>
               <a:t>Fourth Outline Level</a:t>
             </a:r>
-            <a:endParaRPr b="0" lang="fr-FR" sz="2000" strike="noStrike" u="none">
+            <a:endParaRPr b="0" lang="en-US" sz="2000" strike="noStrike" u="none">
               <a:solidFill>
                 <a:srgbClr val="000000"/>
               </a:solidFill>
@@ -3520,7 +3520,7 @@
               </a:rPr>
               <a:t>Fifth Outline Level</a:t>
             </a:r>
-            <a:endParaRPr b="0" lang="fr-FR" sz="2000" strike="noStrike" u="none">
+            <a:endParaRPr b="0" lang="en-US" sz="2000" strike="noStrike" u="none">
               <a:solidFill>
                 <a:srgbClr val="000000"/>
               </a:solidFill>
@@ -3555,7 +3555,7 @@
               </a:rPr>
               <a:t>Sixth Outline Level</a:t>
             </a:r>
-            <a:endParaRPr b="0" lang="fr-FR" sz="2000" strike="noStrike" u="none">
+            <a:endParaRPr b="0" lang="en-US" sz="2000" strike="noStrike" u="none">
               <a:solidFill>
                 <a:srgbClr val="000000"/>
               </a:solidFill>
@@ -3590,7 +3590,7 @@
               </a:rPr>
               <a:t>Seventh Outline Level</a:t>
             </a:r>
-            <a:endParaRPr b="0" lang="fr-FR" sz="2000" strike="noStrike" u="none">
+            <a:endParaRPr b="0" lang="en-US" sz="2000" strike="noStrike" u="none">
               <a:solidFill>
                 <a:srgbClr val="000000"/>
               </a:solidFill>
@@ -3667,7 +3667,7 @@
         <p:spPr>
           <a:xfrm>
             <a:off x="9392760" y="-1425960"/>
-            <a:ext cx="4752720" cy="4752720"/>
+            <a:ext cx="4752360" cy="4752360"/>
           </a:xfrm>
           <a:prstGeom prst="ellipse">
             <a:avLst/>
@@ -3715,7 +3715,7 @@
         <p:spPr>
           <a:xfrm>
             <a:off x="-1828800" y="4206240"/>
-            <a:ext cx="4204080" cy="4204080"/>
+            <a:ext cx="4203720" cy="4203720"/>
           </a:xfrm>
           <a:prstGeom prst="ellipse">
             <a:avLst/>
@@ -3763,7 +3763,7 @@
         <p:spPr>
           <a:xfrm>
             <a:off x="777240" y="1828800"/>
-            <a:ext cx="10513440" cy="1552320"/>
+            <a:ext cx="10513080" cy="1551960"/>
           </a:xfrm>
           <a:prstGeom prst="rect">
             <a:avLst/>
@@ -3804,7 +3804,7 @@
               </a:rPr>
               <a:t>Seeking for AI</a:t>
             </a:r>
-            <a:endParaRPr b="0" lang="fr-FR" sz="5400" strike="noStrike" u="none">
+            <a:endParaRPr b="0" lang="en-US" sz="5400" strike="noStrike" u="none">
               <a:solidFill>
                 <a:srgbClr val="ffffff"/>
               </a:solidFill>
@@ -3824,7 +3824,7 @@
         <p:spPr>
           <a:xfrm>
             <a:off x="822960" y="3246120"/>
-            <a:ext cx="6347880" cy="546480"/>
+            <a:ext cx="6347520" cy="546120"/>
           </a:xfrm>
           <a:prstGeom prst="rect">
             <a:avLst/>
@@ -3871,7 +3871,7 @@
               </a:rPr>
               <a:t>Realistic Datasets for Photons and Neutrons AI methodologies</a:t>
             </a:r>
-            <a:endParaRPr b="0" lang="fr-FR" sz="1900" strike="noStrike" u="none">
+            <a:endParaRPr b="0" lang="en-US" sz="1900" strike="noStrike" u="none">
               <a:solidFill>
                 <a:srgbClr val="ffffff"/>
               </a:solidFill>
@@ -3891,7 +3891,7 @@
         <p:spPr>
           <a:xfrm>
             <a:off x="822960" y="4160520"/>
-            <a:ext cx="1415160" cy="308880"/>
+            <a:ext cx="1414800" cy="308520"/>
           </a:xfrm>
           <a:prstGeom prst="roundRect">
             <a:avLst>
@@ -3941,7 +3941,7 @@
         <p:spPr>
           <a:xfrm>
             <a:off x="822960" y="4160520"/>
-            <a:ext cx="1415160" cy="308880"/>
+            <a:ext cx="1414800" cy="308520"/>
           </a:xfrm>
           <a:prstGeom prst="rect">
             <a:avLst/>
@@ -3982,7 +3982,7 @@
               </a:rPr>
               <a:t>McStas — neutrons</a:t>
             </a:r>
-            <a:endParaRPr b="0" lang="fr-FR" sz="1100" strike="noStrike" u="none">
+            <a:endParaRPr b="0" lang="en-US" sz="1100" strike="noStrike" u="none">
               <a:solidFill>
                 <a:srgbClr val="ffffff"/>
               </a:solidFill>
@@ -4002,7 +4002,7 @@
         <p:spPr>
           <a:xfrm>
             <a:off x="2377440" y="4160520"/>
-            <a:ext cx="1415160" cy="308880"/>
+            <a:ext cx="1414800" cy="308520"/>
           </a:xfrm>
           <a:prstGeom prst="roundRect">
             <a:avLst>
@@ -4052,7 +4052,7 @@
         <p:spPr>
           <a:xfrm>
             <a:off x="2377440" y="4160520"/>
-            <a:ext cx="1415160" cy="308880"/>
+            <a:ext cx="1414800" cy="308520"/>
           </a:xfrm>
           <a:prstGeom prst="rect">
             <a:avLst/>
@@ -4093,7 +4093,7 @@
               </a:rPr>
               <a:t>McXtrace — X-rays</a:t>
             </a:r>
-            <a:endParaRPr b="0" lang="fr-FR" sz="1100" strike="noStrike" u="none">
+            <a:endParaRPr b="0" lang="en-US" sz="1100" strike="noStrike" u="none">
               <a:solidFill>
                 <a:srgbClr val="ffffff"/>
               </a:solidFill>
@@ -4156,7 +4156,7 @@
         <p:spPr>
           <a:xfrm>
             <a:off x="822960" y="5897880"/>
-            <a:ext cx="5484240" cy="317880"/>
+            <a:ext cx="5483880" cy="317520"/>
           </a:xfrm>
           <a:prstGeom prst="rect">
             <a:avLst/>
@@ -4197,7 +4197,7 @@
               </a:rPr>
               <a:t>Emmanuel FARHI   ·   Synchrotron SOLEIL – Sept 2026</a:t>
             </a:r>
-            <a:endParaRPr b="0" lang="fr-FR" sz="1250" strike="noStrike" u="none">
+            <a:endParaRPr b="0" lang="en-US" sz="1250" strike="noStrike" u="none">
               <a:solidFill>
                 <a:srgbClr val="ffffff"/>
               </a:solidFill>
@@ -4217,7 +4217,7 @@
         <p:spPr>
           <a:xfrm>
             <a:off x="7429680" y="3759120"/>
-            <a:ext cx="3807720" cy="1496520"/>
+            <a:ext cx="3807360" cy="1496160"/>
           </a:xfrm>
           <a:prstGeom prst="roundRect">
             <a:avLst>
@@ -4275,7 +4275,7 @@
         <p:spPr>
           <a:xfrm>
             <a:off x="7429680" y="5384880"/>
-            <a:ext cx="3807720" cy="277200"/>
+            <a:ext cx="3807360" cy="276840"/>
           </a:xfrm>
           <a:prstGeom prst="rect">
             <a:avLst/>
@@ -4312,7 +4312,7 @@
               </a:rPr>
               <a:t>PaNRAID School  ·  supported by PEPR DIADEM</a:t>
             </a:r>
-            <a:endParaRPr b="0" lang="fr-FR" sz="1300" strike="noStrike" u="none">
+            <a:endParaRPr b="0" lang="en-US" sz="1300" strike="noStrike" u="none">
               <a:solidFill>
                 <a:srgbClr val="ffffff"/>
               </a:solidFill>
@@ -4337,7 +4337,7 @@
         <p:spPr>
           <a:xfrm>
             <a:off x="825480" y="457200"/>
-            <a:ext cx="1395000" cy="714960"/>
+            <a:ext cx="1394640" cy="714600"/>
           </a:xfrm>
           <a:prstGeom prst="rect">
             <a:avLst/>
@@ -4361,7 +4361,7 @@
         <p:spPr>
           <a:xfrm>
             <a:off x="7429680" y="478800"/>
-            <a:ext cx="4537440" cy="671400"/>
+            <a:ext cx="4537080" cy="671040"/>
           </a:xfrm>
           <a:prstGeom prst="rect">
             <a:avLst/>
@@ -4381,9 +4381,9 @@
         <p:grpSpPr>
           <a:xfrm>
             <a:off x="7936200" y="3847680"/>
-            <a:ext cx="2794320" cy="1319400"/>
+            <a:ext cx="2793960" cy="1319040"/>
             <a:chOff x="7936200" y="3847680"/>
-            <a:chExt cx="2794320" cy="1319400"/>
+            <a:chExt cx="2793960" cy="1319040"/>
           </a:xfrm>
         </p:grpSpPr>
         <p:grpSp>
@@ -4395,9 +4395,9 @@
           <p:grpSpPr>
             <a:xfrm>
               <a:off x="9343440" y="3847680"/>
-              <a:ext cx="1387080" cy="1256400"/>
+              <a:ext cx="1386720" cy="1256040"/>
               <a:chOff x="9343440" y="3847680"/>
-              <a:chExt cx="1387080" cy="1256400"/>
+              <a:chExt cx="1386720" cy="1256040"/>
             </a:xfrm>
           </p:grpSpPr>
           <p:pic>
@@ -4414,7 +4414,7 @@
             <p:spPr>
               <a:xfrm>
                 <a:off x="9392760" y="3847680"/>
-                <a:ext cx="1292400" cy="774000"/>
+                <a:ext cx="1292040" cy="773640"/>
               </a:xfrm>
               <a:prstGeom prst="rect">
                 <a:avLst/>
@@ -4438,7 +4438,7 @@
             <p:spPr>
               <a:xfrm>
                 <a:off x="9343440" y="4576320"/>
-                <a:ext cx="961200" cy="463320"/>
+                <a:ext cx="960840" cy="462960"/>
               </a:xfrm>
               <a:prstGeom prst="rect">
                 <a:avLst/>
@@ -4462,7 +4462,7 @@
             <p:spPr>
               <a:xfrm>
                 <a:off x="10378800" y="4584960"/>
-                <a:ext cx="351720" cy="519120"/>
+                <a:ext cx="351360" cy="518760"/>
               </a:xfrm>
               <a:prstGeom prst="rect">
                 <a:avLst/>
@@ -4487,7 +4487,7 @@
           <p:spPr>
             <a:xfrm>
               <a:off x="7936200" y="3852360"/>
-              <a:ext cx="1292400" cy="1314720"/>
+              <a:ext cx="1292040" cy="1314360"/>
             </a:xfrm>
             <a:prstGeom prst="rect">
               <a:avLst/>
@@ -4538,14 +4538,14 @@
       </p:grpSpPr>
       <p:sp>
         <p:nvSpPr>
-          <p:cNvPr id="73" name="Text 31"/>
+          <p:cNvPr id="74" name="Text 31"/>
           <p:cNvSpPr/>
           <p:nvPr/>
         </p:nvSpPr>
         <p:spPr>
           <a:xfrm>
             <a:off x="548640" y="384120"/>
-            <a:ext cx="9141840" cy="290520"/>
+            <a:ext cx="9141480" cy="290160"/>
           </a:xfrm>
           <a:prstGeom prst="rect">
             <a:avLst/>
@@ -4585,7 +4585,7 @@
               </a:rPr>
               <a:t>Realistic datasets</a:t>
             </a:r>
-            <a:endParaRPr b="0" lang="fr-FR" sz="1200" strike="noStrike" u="none">
+            <a:endParaRPr b="0" lang="en-US" sz="1200" strike="noStrike" u="none">
               <a:solidFill>
                 <a:srgbClr val="000000"/>
               </a:solidFill>
@@ -4598,14 +4598,14 @@
       </p:sp>
       <p:sp>
         <p:nvSpPr>
-          <p:cNvPr id="74" name="Text 32"/>
+          <p:cNvPr id="75" name="Text 32"/>
           <p:cNvSpPr/>
           <p:nvPr/>
         </p:nvSpPr>
         <p:spPr>
           <a:xfrm>
             <a:off x="548640" y="658440"/>
-            <a:ext cx="11062080" cy="820800"/>
+            <a:ext cx="11061720" cy="820440"/>
           </a:xfrm>
           <a:prstGeom prst="rect">
             <a:avLst/>
@@ -4651,7 +4651,7 @@
               </a:rPr>
               <a:t>Why Realistic AI Datasets?</a:t>
             </a:r>
-            <a:endParaRPr b="0" lang="fr-FR" sz="3000" strike="noStrike" u="none">
+            <a:endParaRPr b="0" lang="en-US" sz="3000" strike="noStrike" u="none">
               <a:solidFill>
                 <a:srgbClr val="000000"/>
               </a:solidFill>
@@ -4664,14 +4664,14 @@
       </p:sp>
       <p:sp>
         <p:nvSpPr>
-          <p:cNvPr id="75" name="Text 33"/>
+          <p:cNvPr id="76" name="Text 33"/>
           <p:cNvSpPr/>
           <p:nvPr/>
         </p:nvSpPr>
         <p:spPr>
           <a:xfrm>
             <a:off x="11185920" y="6446520"/>
-            <a:ext cx="455040" cy="272160"/>
+            <a:ext cx="454680" cy="271800"/>
           </a:xfrm>
           <a:prstGeom prst="rect">
             <a:avLst/>
@@ -4712,7 +4712,7 @@
               </a:rPr>
               <a:t>2</a:t>
             </a:r>
-            <a:endParaRPr b="0" lang="fr-FR" sz="900" strike="noStrike" u="none">
+            <a:endParaRPr b="0" lang="en-US" sz="900" strike="noStrike" u="none">
               <a:solidFill>
                 <a:srgbClr val="000000"/>
               </a:solidFill>
@@ -4725,14 +4725,14 @@
       </p:sp>
       <p:sp>
         <p:nvSpPr>
-          <p:cNvPr id="76" name=""/>
+          <p:cNvPr id="77" name=""/>
           <p:cNvSpPr/>
           <p:nvPr/>
         </p:nvSpPr>
         <p:spPr>
           <a:xfrm>
             <a:off x="540000" y="1800000"/>
-            <a:ext cx="10978560" cy="3160080"/>
+            <a:ext cx="10978200" cy="3160080"/>
           </a:xfrm>
           <a:prstGeom prst="rect">
             <a:avLst/>
@@ -4789,7 +4789,7 @@
             <a:br>
               <a:rPr sz="2400"/>
             </a:br>
-            <a:endParaRPr b="0" lang="fr-FR" sz="2400" strike="noStrike" u="none">
+            <a:endParaRPr b="0" lang="en-US" sz="2400" strike="noStrike" u="none">
               <a:solidFill>
                 <a:srgbClr val="000000"/>
               </a:solidFill>
@@ -4837,7 +4837,7 @@
               </a:rPr>
               <a:t>: Find best parameters to get min/max signal.</a:t>
             </a:r>
-            <a:endParaRPr b="0" lang="fr-FR" sz="2400" strike="noStrike" u="none">
+            <a:endParaRPr b="0" lang="en-US" sz="2400" strike="noStrike" u="none">
               <a:solidFill>
                 <a:srgbClr val="000000"/>
               </a:solidFill>
@@ -4899,7 +4899,7 @@
               </a:rPr>
               <a:t> </a:t>
             </a:r>
-            <a:endParaRPr b="0" lang="fr-FR" sz="2400" strike="noStrike" u="none">
+            <a:endParaRPr b="0" lang="en-US" sz="2400" strike="noStrike" u="none">
               <a:solidFill>
                 <a:srgbClr val="000000"/>
               </a:solidFill>
@@ -4934,7 +4934,7 @@
             <a:br>
               <a:rPr sz="2100"/>
             </a:br>
-            <a:endParaRPr b="0" lang="fr-FR" sz="2100" strike="noStrike" u="none">
+            <a:endParaRPr b="0" lang="en-US" sz="2100" strike="noStrike" u="none">
               <a:solidFill>
                 <a:srgbClr val="000000"/>
               </a:solidFill>
@@ -4982,7 +4982,7 @@
               </a:rPr>
               <a:t>: Optimization of beamline configurations.</a:t>
             </a:r>
-            <a:endParaRPr b="0" lang="fr-FR" sz="2400" strike="noStrike" u="none">
+            <a:endParaRPr b="0" lang="en-US" sz="2400" strike="noStrike" u="none">
               <a:solidFill>
                 <a:srgbClr val="000000"/>
               </a:solidFill>
@@ -5025,14 +5025,14 @@
       </p:grpSpPr>
       <p:sp>
         <p:nvSpPr>
-          <p:cNvPr id="77" name="Text 34"/>
+          <p:cNvPr id="78" name="Text 34"/>
           <p:cNvSpPr/>
           <p:nvPr/>
         </p:nvSpPr>
         <p:spPr>
           <a:xfrm>
             <a:off x="548640" y="384120"/>
-            <a:ext cx="9141840" cy="290520"/>
+            <a:ext cx="9141480" cy="290160"/>
           </a:xfrm>
           <a:prstGeom prst="rect">
             <a:avLst/>
@@ -5078,7 +5078,7 @@
               </a:rPr>
               <a:t>General AI Methodology</a:t>
             </a:r>
-            <a:endParaRPr b="0" lang="fr-FR" sz="1200" strike="noStrike" u="none">
+            <a:endParaRPr b="0" lang="en-US" sz="1200" strike="noStrike" u="none">
               <a:solidFill>
                 <a:srgbClr val="000000"/>
               </a:solidFill>
@@ -5091,14 +5091,14 @@
       </p:sp>
       <p:sp>
         <p:nvSpPr>
-          <p:cNvPr id="78" name="Text 35"/>
+          <p:cNvPr id="79" name="Text 35"/>
           <p:cNvSpPr/>
           <p:nvPr/>
         </p:nvSpPr>
         <p:spPr>
           <a:xfrm>
             <a:off x="548640" y="658440"/>
-            <a:ext cx="11062080" cy="820800"/>
+            <a:ext cx="11061720" cy="820440"/>
           </a:xfrm>
           <a:prstGeom prst="rect">
             <a:avLst/>
@@ -5144,7 +5144,7 @@
               </a:rPr>
               <a:t>General AI Methodology</a:t>
             </a:r>
-            <a:endParaRPr b="0" lang="fr-FR" sz="3000" strike="noStrike" u="none">
+            <a:endParaRPr b="0" lang="en-US" sz="3000" strike="noStrike" u="none">
               <a:solidFill>
                 <a:srgbClr val="000000"/>
               </a:solidFill>
@@ -5157,14 +5157,14 @@
       </p:sp>
       <p:sp>
         <p:nvSpPr>
-          <p:cNvPr id="79" name="Text 36"/>
+          <p:cNvPr id="80" name="Text 36"/>
           <p:cNvSpPr/>
           <p:nvPr/>
         </p:nvSpPr>
         <p:spPr>
           <a:xfrm>
             <a:off x="11185920" y="6446520"/>
-            <a:ext cx="455040" cy="272160"/>
+            <a:ext cx="454680" cy="271800"/>
           </a:xfrm>
           <a:prstGeom prst="rect">
             <a:avLst/>
@@ -5205,7 +5205,7 @@
               </a:rPr>
               <a:t>2</a:t>
             </a:r>
-            <a:endParaRPr b="0" lang="fr-FR" sz="900" strike="noStrike" u="none">
+            <a:endParaRPr b="0" lang="en-US" sz="900" strike="noStrike" u="none">
               <a:solidFill>
                 <a:srgbClr val="000000"/>
               </a:solidFill>
@@ -5218,14 +5218,14 @@
       </p:sp>
       <p:sp>
         <p:nvSpPr>
-          <p:cNvPr id="80" name=""/>
+          <p:cNvPr id="81" name=""/>
           <p:cNvSpPr/>
           <p:nvPr/>
         </p:nvSpPr>
         <p:spPr>
           <a:xfrm>
             <a:off x="540000" y="1800000"/>
-            <a:ext cx="10978560" cy="4604760"/>
+            <a:ext cx="10978200" cy="4604760"/>
           </a:xfrm>
           <a:prstGeom prst="rect">
             <a:avLst/>
@@ -5287,7 +5287,7 @@
               </a:rPr>
               <a:t>:</a:t>
             </a:r>
-            <a:endParaRPr b="0" lang="fr-FR" sz="2400" strike="noStrike" u="none">
+            <a:endParaRPr b="0" lang="en-US" sz="2400" strike="noStrike" u="none">
               <a:solidFill>
                 <a:srgbClr val="000000"/>
               </a:solidFill>
@@ -5335,7 +5335,7 @@
               </a:rPr>
               <a:t> </a:t>
             </a:r>
-            <a:endParaRPr b="0" lang="fr-FR" sz="2400" strike="noStrike" u="none">
+            <a:endParaRPr b="0" lang="en-US" sz="2400" strike="noStrike" u="none">
               <a:solidFill>
                 <a:srgbClr val="000000"/>
               </a:solidFill>
@@ -5367,7 +5367,7 @@
             <a:br>
               <a:rPr sz="2400"/>
             </a:br>
-            <a:endParaRPr b="0" lang="fr-FR" sz="2400" strike="noStrike" u="none">
+            <a:endParaRPr b="0" lang="en-US" sz="2400" strike="noStrike" u="none">
               <a:solidFill>
                 <a:srgbClr val="000000"/>
               </a:solidFill>
@@ -5477,7 +5477,7 @@
               </a:rPr>
               <a:t> </a:t>
             </a:r>
-            <a:endParaRPr b="0" lang="fr-FR" sz="2400" strike="noStrike" u="none">
+            <a:endParaRPr b="0" lang="en-US" sz="2400" strike="noStrike" u="none">
               <a:solidFill>
                 <a:srgbClr val="000000"/>
               </a:solidFill>
@@ -5512,7 +5512,7 @@
               </a:rPr>
               <a:t>General Behavior:</a:t>
             </a:r>
-            <a:endParaRPr b="0" lang="fr-FR" sz="2400" strike="noStrike" u="none">
+            <a:endParaRPr b="0" lang="en-US" sz="2400" strike="noStrike" u="none">
               <a:solidFill>
                 <a:srgbClr val="000000"/>
               </a:solidFill>
@@ -5547,7 +5547,7 @@
               </a:rPr>
               <a:t>All AI methods (CNNs, RNNs, SVMs) follow the same principle: map inputs to outputs via learned weights.</a:t>
             </a:r>
-            <a:endParaRPr b="0" lang="fr-FR" sz="2400" strike="noStrike" u="none">
+            <a:endParaRPr b="0" lang="en-US" sz="2400" strike="noStrike" u="none">
               <a:solidFill>
                 <a:srgbClr val="000000"/>
               </a:solidFill>
@@ -5582,7 +5582,7 @@
               </a:rPr>
               <a:t>Differences lie in architecture, training efficiency, and interpretability.</a:t>
             </a:r>
-            <a:endParaRPr b="0" lang="fr-FR" sz="2400" strike="noStrike" u="none">
+            <a:endParaRPr b="0" lang="en-US" sz="2400" strike="noStrike" u="none">
               <a:solidFill>
                 <a:srgbClr val="000000"/>
               </a:solidFill>
@@ -5625,14 +5625,14 @@
       </p:grpSpPr>
       <p:sp>
         <p:nvSpPr>
-          <p:cNvPr id="81" name="Text 37"/>
+          <p:cNvPr id="82" name="Text 37"/>
           <p:cNvSpPr/>
           <p:nvPr/>
         </p:nvSpPr>
         <p:spPr>
           <a:xfrm>
             <a:off x="548640" y="384120"/>
-            <a:ext cx="9141840" cy="290520"/>
+            <a:ext cx="9141480" cy="290160"/>
           </a:xfrm>
           <a:prstGeom prst="rect">
             <a:avLst/>
@@ -5678,7 +5678,7 @@
               </a:rPr>
               <a:t>General AI Methodology</a:t>
             </a:r>
-            <a:endParaRPr b="0" lang="fr-FR" sz="1200" strike="noStrike" u="none">
+            <a:endParaRPr b="0" lang="en-US" sz="1200" strike="noStrike" u="none">
               <a:solidFill>
                 <a:srgbClr val="000000"/>
               </a:solidFill>
@@ -5691,14 +5691,14 @@
       </p:sp>
       <p:sp>
         <p:nvSpPr>
-          <p:cNvPr id="82" name="Text 38"/>
+          <p:cNvPr id="83" name="Text 38"/>
           <p:cNvSpPr/>
           <p:nvPr/>
         </p:nvSpPr>
         <p:spPr>
           <a:xfrm>
             <a:off x="548640" y="658440"/>
-            <a:ext cx="11062080" cy="820800"/>
+            <a:ext cx="11061720" cy="820440"/>
           </a:xfrm>
           <a:prstGeom prst="rect">
             <a:avLst/>
@@ -5744,7 +5744,7 @@
               </a:rPr>
               <a:t>General AI Methodology</a:t>
             </a:r>
-            <a:endParaRPr b="0" lang="fr-FR" sz="3000" strike="noStrike" u="none">
+            <a:endParaRPr b="0" lang="en-US" sz="3000" strike="noStrike" u="none">
               <a:solidFill>
                 <a:srgbClr val="000000"/>
               </a:solidFill>
@@ -5757,14 +5757,14 @@
       </p:sp>
       <p:sp>
         <p:nvSpPr>
-          <p:cNvPr id="83" name="Text 39"/>
+          <p:cNvPr id="84" name="Text 39"/>
           <p:cNvSpPr/>
           <p:nvPr/>
         </p:nvSpPr>
         <p:spPr>
           <a:xfrm>
             <a:off x="11185920" y="6446520"/>
-            <a:ext cx="455040" cy="272160"/>
+            <a:ext cx="454680" cy="271800"/>
           </a:xfrm>
           <a:prstGeom prst="rect">
             <a:avLst/>
@@ -5805,7 +5805,7 @@
               </a:rPr>
               <a:t>2</a:t>
             </a:r>
-            <a:endParaRPr b="0" lang="fr-FR" sz="900" strike="noStrike" u="none">
+            <a:endParaRPr b="0" lang="en-US" sz="900" strike="noStrike" u="none">
               <a:solidFill>
                 <a:srgbClr val="000000"/>
               </a:solidFill>
@@ -5818,14 +5818,14 @@
       </p:sp>
       <p:sp>
         <p:nvSpPr>
-          <p:cNvPr id="84" name=""/>
+          <p:cNvPr id="85" name=""/>
           <p:cNvSpPr/>
           <p:nvPr/>
         </p:nvSpPr>
         <p:spPr>
           <a:xfrm>
             <a:off x="540000" y="1800000"/>
-            <a:ext cx="10978560" cy="4604760"/>
+            <a:ext cx="10978200" cy="4604760"/>
           </a:xfrm>
           <a:prstGeom prst="rect">
             <a:avLst/>
@@ -5890,7 +5890,7 @@
               </a:rPr>
               <a:t> </a:t>
             </a:r>
-            <a:endParaRPr b="0" lang="fr-FR" sz="2400" strike="noStrike" u="none">
+            <a:endParaRPr b="0" lang="en-US" sz="2400" strike="noStrike" u="none">
               <a:solidFill>
                 <a:srgbClr val="000000"/>
               </a:solidFill>
@@ -5937,7 +5937,7 @@
               </a:rPr>
               <a:t>: Minimize the loss function (e.g., Mean Squared Error, Cross-Entropy).</a:t>
             </a:r>
-            <a:endParaRPr b="0" lang="fr-FR" sz="2400" strike="noStrike" u="none">
+            <a:endParaRPr b="0" lang="en-US" sz="2400" strike="noStrike" u="none">
               <a:solidFill>
                 <a:srgbClr val="000000"/>
               </a:solidFill>
@@ -5972,7 +5972,7 @@
               </a:rPr>
               <a:t>Loss Function: Measures the difference between predicted and actual outputs.</a:t>
             </a:r>
-            <a:endParaRPr b="0" lang="fr-FR" sz="2400" strike="noStrike" u="none">
+            <a:endParaRPr b="0" lang="en-US" sz="2400" strike="noStrike" u="none">
               <a:solidFill>
                 <a:srgbClr val="000000"/>
               </a:solidFill>
@@ -6019,7 +6019,7 @@
               </a:rPr>
               <a:t>:</a:t>
             </a:r>
-            <a:endParaRPr b="0" lang="fr-FR" sz="2400" strike="noStrike" u="none">
+            <a:endParaRPr b="0" lang="en-US" sz="2400" strike="noStrike" u="none">
               <a:solidFill>
                 <a:srgbClr val="000000"/>
               </a:solidFill>
@@ -6054,7 +6054,7 @@
               </a:rPr>
               <a:t>Forward Pass: Compute predictions for a batch of training data.</a:t>
             </a:r>
-            <a:endParaRPr b="0" lang="fr-FR" sz="2400" strike="noStrike" u="none">
+            <a:endParaRPr b="0" lang="en-US" sz="2400" strike="noStrike" u="none">
               <a:solidFill>
                 <a:srgbClr val="000000"/>
               </a:solidFill>
@@ -6089,7 +6089,7 @@
               </a:rPr>
               <a:t>Loss Calculation: Evaluate how far predictions are from true values.</a:t>
             </a:r>
-            <a:endParaRPr b="0" lang="fr-FR" sz="2400" strike="noStrike" u="none">
+            <a:endParaRPr b="0" lang="en-US" sz="2400" strike="noStrike" u="none">
               <a:solidFill>
                 <a:srgbClr val="000000"/>
               </a:solidFill>
@@ -6124,7 +6124,7 @@
               </a:rPr>
               <a:t>Backpropagation: Compute gradients of the loss with respect to weights.</a:t>
             </a:r>
-            <a:endParaRPr b="0" lang="fr-FR" sz="2400" strike="noStrike" u="none">
+            <a:endParaRPr b="0" lang="en-US" sz="2400" strike="noStrike" u="none">
               <a:solidFill>
                 <a:srgbClr val="000000"/>
               </a:solidFill>
@@ -6159,7 +6159,7 @@
               </a:rPr>
               <a:t>Optimization: Update weights using an optimizer (e.g., Adam, SGD).</a:t>
             </a:r>
-            <a:endParaRPr b="0" lang="fr-FR" sz="2400" strike="noStrike" u="none">
+            <a:endParaRPr b="0" lang="en-US" sz="2400" strike="noStrike" u="none">
               <a:solidFill>
                 <a:srgbClr val="000000"/>
               </a:solidFill>
@@ -6177,7 +6177,7 @@
                 <a:tab algn="l" pos="0"/>
               </a:tabLst>
             </a:pPr>
-            <a:endParaRPr b="0" lang="fr-FR" sz="2400" strike="noStrike" u="none">
+            <a:endParaRPr b="0" lang="en-US" sz="2400" strike="noStrike" u="none">
               <a:solidFill>
                 <a:srgbClr val="000000"/>
               </a:solidFill>
@@ -6220,14 +6220,14 @@
       </p:grpSpPr>
       <p:sp>
         <p:nvSpPr>
-          <p:cNvPr id="85" name="Text 40"/>
+          <p:cNvPr id="86" name="Text 40"/>
           <p:cNvSpPr/>
           <p:nvPr/>
         </p:nvSpPr>
         <p:spPr>
           <a:xfrm>
             <a:off x="548640" y="383760"/>
-            <a:ext cx="9141840" cy="290520"/>
+            <a:ext cx="9141480" cy="290160"/>
           </a:xfrm>
           <a:prstGeom prst="rect">
             <a:avLst/>
@@ -6273,7 +6273,7 @@
               </a:rPr>
               <a:t>General AI Methodology</a:t>
             </a:r>
-            <a:endParaRPr b="0" lang="fr-FR" sz="1200" strike="noStrike" u="none">
+            <a:endParaRPr b="0" lang="en-US" sz="1200" strike="noStrike" u="none">
               <a:solidFill>
                 <a:srgbClr val="000000"/>
               </a:solidFill>
@@ -6286,14 +6286,14 @@
       </p:sp>
       <p:sp>
         <p:nvSpPr>
-          <p:cNvPr id="86" name="Text 41"/>
+          <p:cNvPr id="87" name="Text 41"/>
           <p:cNvSpPr/>
           <p:nvPr/>
         </p:nvSpPr>
         <p:spPr>
           <a:xfrm>
             <a:off x="548640" y="658080"/>
-            <a:ext cx="11062080" cy="820800"/>
+            <a:ext cx="11061720" cy="820440"/>
           </a:xfrm>
           <a:prstGeom prst="rect">
             <a:avLst/>
@@ -6339,7 +6339,7 @@
               </a:rPr>
               <a:t>General AI Methodology</a:t>
             </a:r>
-            <a:endParaRPr b="0" lang="fr-FR" sz="3000" strike="noStrike" u="none">
+            <a:endParaRPr b="0" lang="en-US" sz="3000" strike="noStrike" u="none">
               <a:solidFill>
                 <a:srgbClr val="000000"/>
               </a:solidFill>
@@ -6352,14 +6352,14 @@
       </p:sp>
       <p:sp>
         <p:nvSpPr>
-          <p:cNvPr id="87" name="Text 42"/>
+          <p:cNvPr id="88" name="Text 42"/>
           <p:cNvSpPr/>
           <p:nvPr/>
         </p:nvSpPr>
         <p:spPr>
           <a:xfrm>
             <a:off x="11185920" y="6446160"/>
-            <a:ext cx="455040" cy="272160"/>
+            <a:ext cx="454680" cy="271800"/>
           </a:xfrm>
           <a:prstGeom prst="rect">
             <a:avLst/>
@@ -6400,7 +6400,7 @@
               </a:rPr>
               <a:t>2</a:t>
             </a:r>
-            <a:endParaRPr b="0" lang="fr-FR" sz="900" strike="noStrike" u="none">
+            <a:endParaRPr b="0" lang="en-US" sz="900" strike="noStrike" u="none">
               <a:solidFill>
                 <a:srgbClr val="000000"/>
               </a:solidFill>
@@ -6413,14 +6413,14 @@
       </p:sp>
       <p:sp>
         <p:nvSpPr>
-          <p:cNvPr id="88" name=""/>
+          <p:cNvPr id="89" name=""/>
           <p:cNvSpPr/>
           <p:nvPr/>
         </p:nvSpPr>
         <p:spPr>
           <a:xfrm>
             <a:off x="540000" y="1799640"/>
-            <a:ext cx="10978560" cy="2775960"/>
+            <a:ext cx="10978200" cy="2775960"/>
           </a:xfrm>
           <a:prstGeom prst="rect">
             <a:avLst/>
@@ -6471,7 +6471,7 @@
               </a:rPr>
               <a:t>Training: The Core Process</a:t>
             </a:r>
-            <a:endParaRPr b="0" lang="fr-FR" sz="2400" strike="noStrike" u="none">
+            <a:endParaRPr b="0" lang="en-US" sz="2400" strike="noStrike" u="none">
               <a:solidFill>
                 <a:srgbClr val="000000"/>
               </a:solidFill>
@@ -6489,7 +6489,7 @@
                 <a:tab algn="l" pos="0"/>
               </a:tabLst>
             </a:pPr>
-            <a:endParaRPr b="0" lang="fr-FR" sz="2400" strike="noStrike" u="none">
+            <a:endParaRPr b="0" lang="en-US" sz="2400" strike="noStrike" u="none">
               <a:solidFill>
                 <a:srgbClr val="000000"/>
               </a:solidFill>
@@ -6524,7 +6524,7 @@
               </a:rPr>
               <a:t>Key Factors for Success:</a:t>
             </a:r>
-            <a:endParaRPr b="0" lang="fr-FR" sz="2400" strike="noStrike" u="none">
+            <a:endParaRPr b="0" lang="en-US" sz="2400" strike="noStrike" u="none">
               <a:solidFill>
                 <a:srgbClr val="000000"/>
               </a:solidFill>
@@ -6559,7 +6559,7 @@
               </a:rPr>
               <a:t>Data Quality: High-fidelity simulations with diverse parameters.</a:t>
             </a:r>
-            <a:endParaRPr b="0" lang="fr-FR" sz="2400" strike="noStrike" u="none">
+            <a:endParaRPr b="0" lang="en-US" sz="2400" strike="noStrike" u="none">
               <a:solidFill>
                 <a:srgbClr val="000000"/>
               </a:solidFill>
@@ -6594,7 +6594,7 @@
               </a:rPr>
               <a:t>Model Architecture: Match complexity to the problem (e.g., CNNs for images, Transformers for sequences).</a:t>
             </a:r>
-            <a:endParaRPr b="0" lang="fr-FR" sz="2400" strike="noStrike" u="none">
+            <a:endParaRPr b="0" lang="en-US" sz="2400" strike="noStrike" u="none">
               <a:solidFill>
                 <a:srgbClr val="000000"/>
               </a:solidFill>
@@ -6629,7 +6629,7 @@
               </a:rPr>
               <a:t>Hyperparameters: Learning rate, batch size, number of epochs.</a:t>
             </a:r>
-            <a:endParaRPr b="0" lang="fr-FR" sz="2400" strike="noStrike" u="none">
+            <a:endParaRPr b="0" lang="en-US" sz="2400" strike="noStrike" u="none">
               <a:solidFill>
                 <a:srgbClr val="000000"/>
               </a:solidFill>
@@ -6672,14 +6672,14 @@
       </p:grpSpPr>
       <p:sp>
         <p:nvSpPr>
-          <p:cNvPr id="89" name="Text 46"/>
+          <p:cNvPr id="90" name="Text 46"/>
           <p:cNvSpPr/>
           <p:nvPr/>
         </p:nvSpPr>
         <p:spPr>
           <a:xfrm>
             <a:off x="548640" y="383760"/>
-            <a:ext cx="9141840" cy="290520"/>
+            <a:ext cx="9141480" cy="290160"/>
           </a:xfrm>
           <a:prstGeom prst="rect">
             <a:avLst/>
@@ -6725,7 +6725,7 @@
               </a:rPr>
               <a:t>Lessons and praticals</a:t>
             </a:r>
-            <a:endParaRPr b="0" lang="fr-FR" sz="1200" strike="noStrike" u="none">
+            <a:endParaRPr b="0" lang="en-US" sz="1200" strike="noStrike" u="none">
               <a:solidFill>
                 <a:srgbClr val="000000"/>
               </a:solidFill>
@@ -6738,14 +6738,14 @@
       </p:sp>
       <p:sp>
         <p:nvSpPr>
-          <p:cNvPr id="90" name="Text 47"/>
+          <p:cNvPr id="91" name="Text 47"/>
           <p:cNvSpPr/>
           <p:nvPr/>
         </p:nvSpPr>
         <p:spPr>
           <a:xfrm>
             <a:off x="548640" y="658080"/>
-            <a:ext cx="11062080" cy="820800"/>
+            <a:ext cx="11061720" cy="820440"/>
           </a:xfrm>
           <a:prstGeom prst="rect">
             <a:avLst/>
@@ -6791,7 +6791,7 @@
               </a:rPr>
               <a:t>What You Will Learn and Practice</a:t>
             </a:r>
-            <a:endParaRPr b="0" lang="fr-FR" sz="3000" strike="noStrike" u="none">
+            <a:endParaRPr b="0" lang="en-US" sz="3000" strike="noStrike" u="none">
               <a:solidFill>
                 <a:srgbClr val="000000"/>
               </a:solidFill>
@@ -6804,14 +6804,14 @@
       </p:sp>
       <p:sp>
         <p:nvSpPr>
-          <p:cNvPr id="91" name="Text 48"/>
+          <p:cNvPr id="92" name="Text 48"/>
           <p:cNvSpPr/>
           <p:nvPr/>
         </p:nvSpPr>
         <p:spPr>
           <a:xfrm>
             <a:off x="11185920" y="6446160"/>
-            <a:ext cx="455040" cy="272160"/>
+            <a:ext cx="454680" cy="271800"/>
           </a:xfrm>
           <a:prstGeom prst="rect">
             <a:avLst/>
@@ -6852,7 +6852,7 @@
               </a:rPr>
               <a:t>2</a:t>
             </a:r>
-            <a:endParaRPr b="0" lang="fr-FR" sz="900" strike="noStrike" u="none">
+            <a:endParaRPr b="0" lang="en-US" sz="900" strike="noStrike" u="none">
               <a:solidFill>
                 <a:srgbClr val="000000"/>
               </a:solidFill>
@@ -6865,14 +6865,14 @@
       </p:sp>
       <p:sp>
         <p:nvSpPr>
-          <p:cNvPr id="92" name=""/>
+          <p:cNvPr id="93" name=""/>
           <p:cNvSpPr/>
           <p:nvPr/>
         </p:nvSpPr>
         <p:spPr>
           <a:xfrm>
             <a:off x="540000" y="1799640"/>
-            <a:ext cx="10978560" cy="4303080"/>
+            <a:ext cx="10978200" cy="4303080"/>
           </a:xfrm>
           <a:prstGeom prst="rect">
             <a:avLst/>
@@ -6923,7 +6923,7 @@
               </a:rPr>
               <a:t>Hands-on skills</a:t>
             </a:r>
-            <a:endParaRPr b="0" lang="fr-FR" sz="2400" strike="noStrike" u="none">
+            <a:endParaRPr b="0" lang="en-US" sz="2400" strike="noStrike" u="none">
               <a:solidFill>
                 <a:srgbClr val="000000"/>
               </a:solidFill>
@@ -6941,7 +6941,7 @@
                 <a:tab algn="l" pos="0"/>
               </a:tabLst>
             </a:pPr>
-            <a:endParaRPr b="0" lang="fr-FR" sz="1000" strike="noStrike" u="none">
+            <a:endParaRPr b="0" lang="en-US" sz="1000" strike="noStrike" u="none">
               <a:solidFill>
                 <a:srgbClr val="000000"/>
               </a:solidFill>
@@ -6982,7 +6982,7 @@
               </a:rPr>
               <a:t>Setting Up Simulations:</a:t>
             </a:r>
-            <a:endParaRPr b="0" lang="fr-FR" sz="2400" strike="noStrike" u="none">
+            <a:endParaRPr b="0" lang="en-US" sz="2400" strike="noStrike" u="none">
               <a:solidFill>
                 <a:srgbClr val="000000"/>
               </a:solidFill>
@@ -7017,7 +7017,7 @@
               </a:rPr>
               <a:t>Configure beamlines/instruments in McStas (neutrons) and McXtrace (X-rays).</a:t>
             </a:r>
-            <a:endParaRPr b="0" lang="fr-FR" sz="2400" strike="noStrike" u="none">
+            <a:endParaRPr b="0" lang="en-US" sz="2400" strike="noStrike" u="none">
               <a:solidFill>
                 <a:srgbClr val="000000"/>
               </a:solidFill>
@@ -7067,7 +7067,7 @@
               </a:rPr>
               <a:t> </a:t>
             </a:r>
-            <a:endParaRPr b="0" lang="fr-FR" sz="2400" strike="noStrike" u="none">
+            <a:endParaRPr b="0" lang="en-US" sz="2400" strike="noStrike" u="none">
               <a:solidFill>
                 <a:srgbClr val="000000"/>
               </a:solidFill>
@@ -7102,7 +7102,7 @@
               </a:rPr>
               <a:t>Characterizing Models:</a:t>
             </a:r>
-            <a:endParaRPr b="0" lang="fr-FR" sz="2400" strike="noStrike" u="none">
+            <a:endParaRPr b="0" lang="en-US" sz="2400" strike="noStrike" u="none">
               <a:solidFill>
                 <a:srgbClr val="000000"/>
               </a:solidFill>
@@ -7137,7 +7137,7 @@
               </a:rPr>
               <a:t>Check geometry (e.g., detector positions, slit sizes).</a:t>
             </a:r>
-            <a:endParaRPr b="0" lang="fr-FR" sz="2400" strike="noStrike" u="none">
+            <a:endParaRPr b="0" lang="en-US" sz="2400" strike="noStrike" u="none">
               <a:solidFill>
                 <a:srgbClr val="000000"/>
               </a:solidFill>
@@ -7172,7 +7172,7 @@
               </a:rPr>
               <a:t>Extract parameters (e.g., resolution, flux) and results (e.g., spectra, diffraction patterns).</a:t>
             </a:r>
-            <a:endParaRPr b="0" lang="fr-FR" sz="2400" strike="noStrike" u="none">
+            <a:endParaRPr b="0" lang="en-US" sz="2400" strike="noStrike" u="none">
               <a:solidFill>
                 <a:srgbClr val="000000"/>
               </a:solidFill>
@@ -7215,14 +7215,14 @@
       </p:grpSpPr>
       <p:sp>
         <p:nvSpPr>
-          <p:cNvPr id="93" name="Text 43"/>
+          <p:cNvPr id="94" name="Text 43"/>
           <p:cNvSpPr/>
           <p:nvPr/>
         </p:nvSpPr>
         <p:spPr>
           <a:xfrm>
             <a:off x="548640" y="383760"/>
-            <a:ext cx="9141840" cy="290520"/>
+            <a:ext cx="9141480" cy="290160"/>
           </a:xfrm>
           <a:prstGeom prst="rect">
             <a:avLst/>
@@ -7268,7 +7268,7 @@
               </a:rPr>
               <a:t>Lessons and praticals</a:t>
             </a:r>
-            <a:endParaRPr b="0" lang="fr-FR" sz="1200" strike="noStrike" u="none">
+            <a:endParaRPr b="0" lang="en-US" sz="1200" strike="noStrike" u="none">
               <a:solidFill>
                 <a:srgbClr val="000000"/>
               </a:solidFill>
@@ -7281,14 +7281,14 @@
       </p:sp>
       <p:sp>
         <p:nvSpPr>
-          <p:cNvPr id="94" name="Text 44"/>
+          <p:cNvPr id="95" name="Text 44"/>
           <p:cNvSpPr/>
           <p:nvPr/>
         </p:nvSpPr>
         <p:spPr>
           <a:xfrm>
             <a:off x="548640" y="658080"/>
-            <a:ext cx="11062080" cy="820800"/>
+            <a:ext cx="11061720" cy="820440"/>
           </a:xfrm>
           <a:prstGeom prst="rect">
             <a:avLst/>
@@ -7334,7 +7334,7 @@
               </a:rPr>
               <a:t>What You Will Learn and Practice</a:t>
             </a:r>
-            <a:endParaRPr b="0" lang="fr-FR" sz="3000" strike="noStrike" u="none">
+            <a:endParaRPr b="0" lang="en-US" sz="3000" strike="noStrike" u="none">
               <a:solidFill>
                 <a:srgbClr val="000000"/>
               </a:solidFill>
@@ -7347,14 +7347,14 @@
       </p:sp>
       <p:sp>
         <p:nvSpPr>
-          <p:cNvPr id="95" name="Text 45"/>
+          <p:cNvPr id="96" name="Text 45"/>
           <p:cNvSpPr/>
           <p:nvPr/>
         </p:nvSpPr>
         <p:spPr>
           <a:xfrm>
             <a:off x="11185920" y="6446160"/>
-            <a:ext cx="455040" cy="272160"/>
+            <a:ext cx="454680" cy="271800"/>
           </a:xfrm>
           <a:prstGeom prst="rect">
             <a:avLst/>
@@ -7395,7 +7395,7 @@
               </a:rPr>
               <a:t>2</a:t>
             </a:r>
-            <a:endParaRPr b="0" lang="fr-FR" sz="900" strike="noStrike" u="none">
+            <a:endParaRPr b="0" lang="en-US" sz="900" strike="noStrike" u="none">
               <a:solidFill>
                 <a:srgbClr val="000000"/>
               </a:solidFill>
@@ -7408,14 +7408,14 @@
       </p:sp>
       <p:sp>
         <p:nvSpPr>
-          <p:cNvPr id="96" name=""/>
+          <p:cNvPr id="97" name=""/>
           <p:cNvSpPr/>
           <p:nvPr/>
         </p:nvSpPr>
         <p:spPr>
           <a:xfrm>
             <a:off x="540000" y="1799640"/>
-            <a:ext cx="10978560" cy="4336200"/>
+            <a:ext cx="10978200" cy="4336200"/>
           </a:xfrm>
           <a:prstGeom prst="rect">
             <a:avLst/>
@@ -7466,7 +7466,7 @@
               </a:rPr>
               <a:t>Hands-on skills</a:t>
             </a:r>
-            <a:endParaRPr b="0" lang="fr-FR" sz="2400" strike="noStrike" u="none">
+            <a:endParaRPr b="0" lang="en-US" sz="2400" strike="noStrike" u="none">
               <a:solidFill>
                 <a:srgbClr val="000000"/>
               </a:solidFill>
@@ -7484,7 +7484,7 @@
                 <a:tab algn="l" pos="0"/>
               </a:tabLst>
             </a:pPr>
-            <a:endParaRPr b="0" lang="fr-FR" sz="1000" strike="noStrike" u="none">
+            <a:endParaRPr b="0" lang="en-US" sz="1000" strike="noStrike" u="none">
               <a:solidFill>
                 <a:srgbClr val="000000"/>
               </a:solidFill>
@@ -7525,7 +7525,7 @@
               </a:rPr>
               <a:t>Generating Datasets:</a:t>
             </a:r>
-            <a:endParaRPr b="0" lang="fr-FR" sz="2400" strike="noStrike" u="none">
+            <a:endParaRPr b="0" lang="en-US" sz="2400" strike="noStrike" u="none">
               <a:solidFill>
                 <a:srgbClr val="000000"/>
               </a:solidFill>
@@ -7590,7 +7590,7 @@
               </a:rPr>
               <a:t> ranges (e.g., vary samples).</a:t>
             </a:r>
-            <a:endParaRPr b="0" lang="fr-FR" sz="2400" strike="noStrike" u="none">
+            <a:endParaRPr b="0" lang="en-US" sz="2400" strike="noStrike" u="none">
               <a:solidFill>
                 <a:srgbClr val="000000"/>
               </a:solidFill>
@@ -7670,7 +7670,7 @@
               </a:rPr>
               <a:t> </a:t>
             </a:r>
-            <a:endParaRPr b="0" lang="fr-FR" sz="1000" strike="noStrike" u="none">
+            <a:endParaRPr b="0" lang="en-US" sz="1000" strike="noStrike" u="none">
               <a:solidFill>
                 <a:srgbClr val="000000"/>
               </a:solidFill>
@@ -7705,7 +7705,7 @@
               </a:rPr>
               <a:t>Apply AI :</a:t>
             </a:r>
-            <a:endParaRPr b="0" lang="fr-FR" sz="2400" strike="noStrike" u="none">
+            <a:endParaRPr b="0" lang="en-US" sz="2400" strike="noStrike" u="none">
               <a:solidFill>
                 <a:srgbClr val="000000"/>
               </a:solidFill>
@@ -7770,7 +7770,7 @@
               </a:rPr>
               <a:t> faster.</a:t>
             </a:r>
-            <a:endParaRPr b="0" lang="fr-FR" sz="2400" strike="noStrike" u="none">
+            <a:endParaRPr b="0" lang="en-US" sz="2400" strike="noStrike" u="none">
               <a:solidFill>
                 <a:srgbClr val="000000"/>
               </a:solidFill>
@@ -7847,7 +7847,7 @@
               </a:rPr>
               <a:t> measurements.</a:t>
             </a:r>
-            <a:endParaRPr b="0" lang="fr-FR" sz="2400" strike="noStrike" u="none">
+            <a:endParaRPr b="0" lang="en-US" sz="2400" strike="noStrike" u="none">
               <a:solidFill>
                 <a:srgbClr val="000000"/>
               </a:solidFill>
@@ -7900,7 +7900,7 @@
               </a:rPr>
               <a:t>parameters.</a:t>
             </a:r>
-            <a:endParaRPr b="0" lang="fr-FR" sz="2400" strike="noStrike" u="none">
+            <a:endParaRPr b="0" lang="en-US" sz="2400" strike="noStrike" u="none">
               <a:solidFill>
                 <a:srgbClr val="000000"/>
               </a:solidFill>
@@ -7943,14 +7943,14 @@
       </p:grpSpPr>
       <p:sp>
         <p:nvSpPr>
-          <p:cNvPr id="97" name="Text 49"/>
+          <p:cNvPr id="98" name="Text 49"/>
           <p:cNvSpPr/>
           <p:nvPr/>
         </p:nvSpPr>
         <p:spPr>
           <a:xfrm>
             <a:off x="548640" y="383760"/>
-            <a:ext cx="9141840" cy="290520"/>
+            <a:ext cx="9141480" cy="290160"/>
           </a:xfrm>
           <a:prstGeom prst="rect">
             <a:avLst/>
@@ -7996,7 +7996,7 @@
               </a:rPr>
               <a:t>Resources</a:t>
             </a:r>
-            <a:endParaRPr b="0" lang="fr-FR" sz="1200" strike="noStrike" u="none">
+            <a:endParaRPr b="0" lang="en-US" sz="1200" strike="noStrike" u="none">
               <a:solidFill>
                 <a:srgbClr val="000000"/>
               </a:solidFill>
@@ -8009,14 +8009,14 @@
       </p:sp>
       <p:sp>
         <p:nvSpPr>
-          <p:cNvPr id="98" name="Text 50"/>
+          <p:cNvPr id="99" name="Text 50"/>
           <p:cNvSpPr/>
           <p:nvPr/>
         </p:nvSpPr>
         <p:spPr>
           <a:xfrm>
             <a:off x="548640" y="658080"/>
-            <a:ext cx="11062080" cy="820800"/>
+            <a:ext cx="11061720" cy="820440"/>
           </a:xfrm>
           <a:prstGeom prst="rect">
             <a:avLst/>
@@ -8062,7 +8062,7 @@
               </a:rPr>
               <a:t>What You Will Use</a:t>
             </a:r>
-            <a:endParaRPr b="0" lang="fr-FR" sz="3000" strike="noStrike" u="none">
+            <a:endParaRPr b="0" lang="en-US" sz="3000" strike="noStrike" u="none">
               <a:solidFill>
                 <a:srgbClr val="000000"/>
               </a:solidFill>
@@ -8075,14 +8075,14 @@
       </p:sp>
       <p:sp>
         <p:nvSpPr>
-          <p:cNvPr id="99" name="Text 51"/>
+          <p:cNvPr id="100" name="Text 51"/>
           <p:cNvSpPr/>
           <p:nvPr/>
         </p:nvSpPr>
         <p:spPr>
           <a:xfrm>
             <a:off x="11185920" y="6446160"/>
-            <a:ext cx="455040" cy="272160"/>
+            <a:ext cx="454680" cy="271800"/>
           </a:xfrm>
           <a:prstGeom prst="rect">
             <a:avLst/>
@@ -8123,7 +8123,7 @@
               </a:rPr>
               <a:t>2</a:t>
             </a:r>
-            <a:endParaRPr b="0" lang="fr-FR" sz="900" strike="noStrike" u="none">
+            <a:endParaRPr b="0" lang="en-US" sz="900" strike="noStrike" u="none">
               <a:solidFill>
                 <a:srgbClr val="000000"/>
               </a:solidFill>
@@ -8136,14 +8136,14 @@
       </p:sp>
       <p:sp>
         <p:nvSpPr>
-          <p:cNvPr id="100" name=""/>
+          <p:cNvPr id="101" name=""/>
           <p:cNvSpPr/>
           <p:nvPr/>
         </p:nvSpPr>
         <p:spPr>
           <a:xfrm>
             <a:off x="540000" y="1799640"/>
-            <a:ext cx="10978560" cy="2713320"/>
+            <a:ext cx="10978200" cy="2713320"/>
           </a:xfrm>
           <a:prstGeom prst="rect">
             <a:avLst/>
@@ -8194,7 +8194,7 @@
               </a:rPr>
               <a:t>Your Laptop</a:t>
             </a:r>
-            <a:endParaRPr b="0" lang="fr-FR" sz="2400" strike="noStrike" u="none">
+            <a:endParaRPr b="0" lang="en-US" sz="2400" strike="noStrike" u="none">
               <a:solidFill>
                 <a:srgbClr val="000000"/>
               </a:solidFill>
@@ -8234,7 +8234,7 @@
               </a:rPr>
               <a:t>High Performance Computing (MesoNET)</a:t>
             </a:r>
-            <a:endParaRPr b="0" lang="fr-FR" sz="2400" strike="noStrike" u="none">
+            <a:endParaRPr b="0" lang="en-US" sz="2400" strike="noStrike" u="none">
               <a:solidFill>
                 <a:srgbClr val="000000"/>
               </a:solidFill>
@@ -8297,7 +8297,7 @@
               </a:rPr>
               <a:t>)</a:t>
             </a:r>
-            <a:endParaRPr b="0" lang="fr-FR" sz="2400" strike="noStrike" u="none">
+            <a:endParaRPr b="0" lang="en-US" sz="2400" strike="noStrike" u="none">
               <a:solidFill>
                 <a:srgbClr val="000000"/>
               </a:solidFill>
@@ -8337,7 +8337,7 @@
               </a:rPr>
               <a:t>Your Brain</a:t>
             </a:r>
-            <a:endParaRPr b="0" lang="fr-FR" sz="2400" strike="noStrike" u="none">
+            <a:endParaRPr b="0" lang="en-US" sz="2400" strike="noStrike" u="none">
               <a:solidFill>
                 <a:srgbClr val="000000"/>
               </a:solidFill>
@@ -8355,7 +8355,7 @@
                 <a:tab algn="l" pos="0"/>
               </a:tabLst>
             </a:pPr>
-            <a:endParaRPr b="0" lang="fr-FR" sz="1000" strike="noStrike" u="none">
+            <a:endParaRPr b="0" lang="en-US" sz="1000" strike="noStrike" u="none">
               <a:solidFill>
                 <a:srgbClr val="000000"/>
               </a:solidFill>
@@ -8405,14 +8405,14 @@
       </p:grpSpPr>
       <p:sp>
         <p:nvSpPr>
-          <p:cNvPr id="101" name="Shape 0"/>
+          <p:cNvPr id="102" name="Shape 0"/>
           <p:cNvSpPr/>
           <p:nvPr/>
         </p:nvSpPr>
         <p:spPr>
           <a:xfrm>
             <a:off x="9410040" y="-1457640"/>
-            <a:ext cx="4752720" cy="4752720"/>
+            <a:ext cx="4752360" cy="4752360"/>
           </a:xfrm>
           <a:prstGeom prst="ellipse">
             <a:avLst/>
@@ -8453,14 +8453,14 @@
       </p:sp>
       <p:sp>
         <p:nvSpPr>
-          <p:cNvPr id="102" name="Shape 1"/>
+          <p:cNvPr id="103" name="Shape 1"/>
           <p:cNvSpPr/>
           <p:nvPr/>
         </p:nvSpPr>
         <p:spPr>
           <a:xfrm>
             <a:off x="-1828800" y="4206240"/>
-            <a:ext cx="4204080" cy="4204080"/>
+            <a:ext cx="4203720" cy="4203720"/>
           </a:xfrm>
           <a:prstGeom prst="ellipse">
             <a:avLst/>
@@ -8501,14 +8501,14 @@
       </p:sp>
       <p:sp>
         <p:nvSpPr>
-          <p:cNvPr id="103" name="Text 2"/>
+          <p:cNvPr id="104" name="Text 2"/>
           <p:cNvSpPr/>
           <p:nvPr/>
         </p:nvSpPr>
         <p:spPr>
           <a:xfrm>
             <a:off x="822960" y="2286000"/>
-            <a:ext cx="9141840" cy="1095120"/>
+            <a:ext cx="9141480" cy="1094760"/>
           </a:xfrm>
           <a:prstGeom prst="rect">
             <a:avLst/>
@@ -8549,7 +8549,7 @@
               </a:rPr>
               <a:t>Thank you</a:t>
             </a:r>
-            <a:endParaRPr b="0" lang="fr-FR" sz="4800" strike="noStrike" u="none">
+            <a:endParaRPr b="0" lang="en-US" sz="4800" strike="noStrike" u="none">
               <a:solidFill>
                 <a:srgbClr val="ffffff"/>
               </a:solidFill>
@@ -8562,14 +8562,14 @@
       </p:sp>
       <p:sp>
         <p:nvSpPr>
-          <p:cNvPr id="104" name="Text 3"/>
+          <p:cNvPr id="105" name="Text 3"/>
           <p:cNvSpPr/>
           <p:nvPr/>
         </p:nvSpPr>
         <p:spPr>
           <a:xfrm>
             <a:off x="822960" y="3246120"/>
-            <a:ext cx="9141840" cy="637920"/>
+            <a:ext cx="9141480" cy="637560"/>
           </a:xfrm>
           <a:prstGeom prst="rect">
             <a:avLst/>
@@ -8610,7 +8610,7 @@
               </a:rPr>
               <a:t>Questions?</a:t>
             </a:r>
-            <a:endParaRPr b="0" lang="fr-FR" sz="2000" strike="noStrike" u="none">
+            <a:endParaRPr b="0" lang="en-US" sz="2000" strike="noStrike" u="none">
               <a:solidFill>
                 <a:srgbClr val="ffffff"/>
               </a:solidFill>
@@ -8623,14 +8623,14 @@
       </p:sp>
       <p:sp>
         <p:nvSpPr>
-          <p:cNvPr id="105" name="Shape 4"/>
+          <p:cNvPr id="106" name="Shape 4"/>
           <p:cNvSpPr/>
           <p:nvPr/>
         </p:nvSpPr>
         <p:spPr>
           <a:xfrm>
             <a:off x="822960" y="4297680"/>
-            <a:ext cx="1415160" cy="308880"/>
+            <a:ext cx="1414800" cy="308520"/>
           </a:xfrm>
           <a:prstGeom prst="roundRect">
             <a:avLst>
@@ -8673,14 +8673,14 @@
       </p:sp>
       <p:sp>
         <p:nvSpPr>
-          <p:cNvPr id="106" name="Text 5"/>
+          <p:cNvPr id="107" name="Text 5"/>
           <p:cNvSpPr/>
           <p:nvPr/>
         </p:nvSpPr>
         <p:spPr>
           <a:xfrm>
             <a:off x="822960" y="4297680"/>
-            <a:ext cx="1415160" cy="308880"/>
+            <a:ext cx="1414800" cy="308520"/>
           </a:xfrm>
           <a:prstGeom prst="rect">
             <a:avLst/>
@@ -8721,7 +8721,7 @@
               </a:rPr>
               <a:t>mcstas.org</a:t>
             </a:r>
-            <a:endParaRPr b="0" lang="fr-FR" sz="1100" strike="noStrike" u="none">
+            <a:endParaRPr b="0" lang="en-US" sz="1100" strike="noStrike" u="none">
               <a:solidFill>
                 <a:srgbClr val="ffffff"/>
               </a:solidFill>
@@ -8734,14 +8734,14 @@
       </p:sp>
       <p:sp>
         <p:nvSpPr>
-          <p:cNvPr id="107" name="Shape 6"/>
+          <p:cNvPr id="108" name="Shape 6"/>
           <p:cNvSpPr/>
           <p:nvPr/>
         </p:nvSpPr>
         <p:spPr>
           <a:xfrm>
             <a:off x="2377440" y="4297680"/>
-            <a:ext cx="1415160" cy="308880"/>
+            <a:ext cx="1414800" cy="308520"/>
           </a:xfrm>
           <a:prstGeom prst="roundRect">
             <a:avLst>
@@ -8784,14 +8784,14 @@
       </p:sp>
       <p:sp>
         <p:nvSpPr>
-          <p:cNvPr id="108" name="Text 7"/>
+          <p:cNvPr id="109" name="Text 7"/>
           <p:cNvSpPr/>
           <p:nvPr/>
         </p:nvSpPr>
         <p:spPr>
           <a:xfrm>
             <a:off x="2377440" y="4297680"/>
-            <a:ext cx="1415160" cy="308880"/>
+            <a:ext cx="1414800" cy="308520"/>
           </a:xfrm>
           <a:prstGeom prst="rect">
             <a:avLst/>
@@ -8832,7 +8832,7 @@
               </a:rPr>
               <a:t>mcxtrace.org</a:t>
             </a:r>
-            <a:endParaRPr b="0" lang="fr-FR" sz="1100" strike="noStrike" u="none">
+            <a:endParaRPr b="0" lang="en-US" sz="1100" strike="noStrike" u="none">
               <a:solidFill>
                 <a:srgbClr val="ffffff"/>
               </a:solidFill>
@@ -8845,7 +8845,7 @@
       </p:sp>
       <p:sp>
         <p:nvSpPr>
-          <p:cNvPr id="109" name="Shape 8"/>
+          <p:cNvPr id="110" name="Shape 8"/>
           <p:cNvSpPr/>
           <p:nvPr/>
         </p:nvSpPr>
@@ -8888,14 +8888,14 @@
       </p:sp>
       <p:sp>
         <p:nvSpPr>
-          <p:cNvPr id="110" name="Text 9"/>
+          <p:cNvPr id="111" name="Text 9"/>
           <p:cNvSpPr/>
           <p:nvPr/>
         </p:nvSpPr>
         <p:spPr>
           <a:xfrm>
             <a:off x="822960" y="5897880"/>
-            <a:ext cx="7313040" cy="317880"/>
+            <a:ext cx="7312680" cy="317520"/>
           </a:xfrm>
           <a:prstGeom prst="rect">
             <a:avLst/>
@@ -8936,7 +8936,7 @@
               </a:rPr>
               <a:t>Peter Willendrup   ·   pkwi@fysik.dtu.dk   ·   DTU Physics</a:t>
             </a:r>
-            <a:endParaRPr b="0" lang="fr-FR" sz="1250" strike="noStrike" u="none">
+            <a:endParaRPr b="0" lang="en-US" sz="1250" strike="noStrike" u="none">
               <a:solidFill>
                 <a:srgbClr val="ffffff"/>
               </a:solidFill>
@@ -8949,14 +8949,14 @@
       </p:sp>
       <p:sp>
         <p:nvSpPr>
-          <p:cNvPr id="111" name="Text 10"/>
+          <p:cNvPr id="112" name="Text 10"/>
           <p:cNvSpPr/>
           <p:nvPr/>
         </p:nvSpPr>
         <p:spPr>
           <a:xfrm>
             <a:off x="548640" y="6446520"/>
-            <a:ext cx="6398640" cy="272160"/>
+            <a:ext cx="6398280" cy="271800"/>
           </a:xfrm>
           <a:prstGeom prst="rect">
             <a:avLst/>
@@ -8997,7 +8997,7 @@
               </a:rPr>
               <a:t>{presentation title</a:t>
             </a:r>
-            <a:endParaRPr b="0" lang="fr-FR" sz="900" strike="noStrike" u="none">
+            <a:endParaRPr b="0" lang="en-US" sz="900" strike="noStrike" u="none">
               <a:solidFill>
                 <a:srgbClr val="ffffff"/>
               </a:solidFill>
@@ -9010,14 +9010,14 @@
       </p:sp>
       <p:sp>
         <p:nvSpPr>
-          <p:cNvPr id="112" name="Text 11"/>
+          <p:cNvPr id="113" name="Text 11"/>
           <p:cNvSpPr/>
           <p:nvPr/>
         </p:nvSpPr>
         <p:spPr>
           <a:xfrm>
             <a:off x="11185920" y="6446520"/>
-            <a:ext cx="455040" cy="272160"/>
+            <a:ext cx="454680" cy="271800"/>
           </a:xfrm>
           <a:prstGeom prst="rect">
             <a:avLst/>
@@ -9058,7 +9058,7 @@
               </a:rPr>
               <a:t>17</a:t>
             </a:r>
-            <a:endParaRPr b="0" lang="fr-FR" sz="900" strike="noStrike" u="none">
+            <a:endParaRPr b="0" lang="en-US" sz="900" strike="noStrike" u="none">
               <a:solidFill>
                 <a:srgbClr val="ffffff"/>
               </a:solidFill>
@@ -9071,14 +9071,14 @@
       </p:sp>
       <p:sp>
         <p:nvSpPr>
-          <p:cNvPr id="113" name="PartnerCard"/>
+          <p:cNvPr id="114" name="PartnerCard"/>
           <p:cNvSpPr/>
           <p:nvPr/>
         </p:nvSpPr>
         <p:spPr>
           <a:xfrm>
             <a:off x="6603840" y="4165560"/>
-            <a:ext cx="4950720" cy="1572480"/>
+            <a:ext cx="4950360" cy="1572120"/>
           </a:xfrm>
           <a:prstGeom prst="roundRect">
             <a:avLst>
@@ -9129,14 +9129,14 @@
       </p:sp>
       <p:sp>
         <p:nvSpPr>
-          <p:cNvPr id="114" name="PartnerLabel"/>
+          <p:cNvPr id="115" name="PartnerLabel"/>
           <p:cNvSpPr/>
           <p:nvPr/>
         </p:nvSpPr>
         <p:spPr>
           <a:xfrm>
             <a:off x="6921360" y="4368960"/>
-            <a:ext cx="4315680" cy="226440"/>
+            <a:ext cx="4315320" cy="226080"/>
           </a:xfrm>
           <a:prstGeom prst="rect">
             <a:avLst/>
@@ -9173,7 +9173,7 @@
               </a:rPr>
               <a:t>SUPPORTED BY</a:t>
             </a:r>
-            <a:endParaRPr b="0" lang="fr-FR" sz="1100" strike="noStrike" u="none">
+            <a:endParaRPr b="0" lang="en-US" sz="1100" strike="noStrike" u="none">
               <a:solidFill>
                 <a:srgbClr val="ffffff"/>
               </a:solidFill>
@@ -9186,7 +9186,7 @@
       </p:sp>
       <p:pic>
         <p:nvPicPr>
-          <p:cNvPr id="115" name="Picture 15" descr=""/>
+          <p:cNvPr id="116" name="Picture 15" descr=""/>
           <p:cNvPicPr/>
           <p:nvPr/>
         </p:nvPicPr>
@@ -9197,7 +9197,7 @@
         <p:spPr>
           <a:xfrm>
             <a:off x="6921360" y="4749840"/>
-            <a:ext cx="4315680" cy="638280"/>
+            <a:ext cx="4315320" cy="637920"/>
           </a:xfrm>
           <a:prstGeom prst="rect">
             <a:avLst/>
@@ -9210,7 +9210,7 @@
       </p:pic>
       <p:pic>
         <p:nvPicPr>
-          <p:cNvPr id="116" name="Copied Picture 17" descr=""/>
+          <p:cNvPr id="117" name="Copied Picture 17" descr=""/>
           <p:cNvPicPr/>
           <p:nvPr/>
         </p:nvPicPr>
@@ -9222,7 +9222,7 @@
         <p:spPr>
           <a:xfrm>
             <a:off x="10375920" y="355680"/>
-            <a:ext cx="1267920" cy="649440"/>
+            <a:ext cx="1267560" cy="649080"/>
           </a:xfrm>
           <a:prstGeom prst="rect">
             <a:avLst/>
@@ -9235,14 +9235,14 @@
       </p:pic>
       <p:sp>
         <p:nvSpPr>
-          <p:cNvPr id="117" name="LogoCard"/>
+          <p:cNvPr id="118" name="LogoCard"/>
           <p:cNvSpPr/>
           <p:nvPr/>
         </p:nvSpPr>
         <p:spPr>
           <a:xfrm>
             <a:off x="7375680" y="2105640"/>
-            <a:ext cx="3807720" cy="1496520"/>
+            <a:ext cx="3807360" cy="1496160"/>
           </a:xfrm>
           <a:prstGeom prst="roundRect">
             <a:avLst>
@@ -9293,35 +9293,35 @@
       </p:sp>
       <p:grpSp>
         <p:nvGrpSpPr>
-          <p:cNvPr id="118" name="Group 18"/>
+          <p:cNvPr id="119" name="Group 18"/>
           <p:cNvGrpSpPr/>
           <p:nvPr/>
         </p:nvGrpSpPr>
         <p:grpSpPr>
           <a:xfrm>
             <a:off x="7882560" y="2194200"/>
-            <a:ext cx="2794320" cy="1319400"/>
+            <a:ext cx="2793960" cy="1319040"/>
             <a:chOff x="7882560" y="2194200"/>
-            <a:chExt cx="2794320" cy="1319400"/>
+            <a:chExt cx="2793960" cy="1319040"/>
           </a:xfrm>
         </p:grpSpPr>
         <p:grpSp>
           <p:nvGrpSpPr>
-            <p:cNvPr id="119" name="Group 19"/>
+            <p:cNvPr id="120" name="Group 19"/>
             <p:cNvGrpSpPr/>
             <p:nvPr/>
           </p:nvGrpSpPr>
           <p:grpSpPr>
             <a:xfrm>
               <a:off x="9289440" y="2194200"/>
-              <a:ext cx="1387440" cy="1256400"/>
+              <a:ext cx="1387080" cy="1256040"/>
               <a:chOff x="9289440" y="2194200"/>
-              <a:chExt cx="1387440" cy="1256400"/>
+              <a:chExt cx="1387080" cy="1256040"/>
             </a:xfrm>
           </p:grpSpPr>
           <p:pic>
             <p:nvPicPr>
-              <p:cNvPr id="120" name="Picture 21" descr=""/>
+              <p:cNvPr id="121" name="Picture 21" descr=""/>
               <p:cNvPicPr/>
               <p:nvPr/>
             </p:nvPicPr>
@@ -9333,7 +9333,7 @@
             <p:spPr>
               <a:xfrm>
                 <a:off x="9339120" y="2194200"/>
-                <a:ext cx="1292400" cy="774000"/>
+                <a:ext cx="1292040" cy="773640"/>
               </a:xfrm>
               <a:prstGeom prst="rect">
                 <a:avLst/>
@@ -9346,7 +9346,7 @@
           </p:pic>
           <p:pic>
             <p:nvPicPr>
-              <p:cNvPr id="121" name="Picture 22" descr="Synchrotron SOLEIL"/>
+              <p:cNvPr id="122" name="Picture 22" descr="Synchrotron SOLEIL"/>
               <p:cNvPicPr/>
               <p:nvPr/>
             </p:nvPicPr>
@@ -9357,7 +9357,7 @@
             <p:spPr>
               <a:xfrm>
                 <a:off x="9289440" y="2922840"/>
-                <a:ext cx="961200" cy="463320"/>
+                <a:ext cx="960840" cy="462960"/>
               </a:xfrm>
               <a:prstGeom prst="rect">
                 <a:avLst/>
@@ -9370,7 +9370,7 @@
           </p:pic>
           <p:pic>
             <p:nvPicPr>
-              <p:cNvPr id="122" name="Picture 23" descr="DTU Physics"/>
+              <p:cNvPr id="123" name="Picture 23" descr="DTU Physics"/>
               <p:cNvPicPr/>
               <p:nvPr/>
             </p:nvPicPr>
@@ -9381,7 +9381,7 @@
             <p:spPr>
               <a:xfrm>
                 <a:off x="10325160" y="2931480"/>
-                <a:ext cx="351720" cy="519120"/>
+                <a:ext cx="351360" cy="518760"/>
               </a:xfrm>
               <a:prstGeom prst="rect">
                 <a:avLst/>
@@ -9395,7 +9395,7 @@
         </p:grpSp>
         <p:pic>
           <p:nvPicPr>
-            <p:cNvPr id="123" name="Picture 20" descr=""/>
+            <p:cNvPr id="124" name="Picture 20" descr=""/>
             <p:cNvPicPr/>
             <p:nvPr/>
           </p:nvPicPr>
@@ -9406,7 +9406,7 @@
           <p:spPr>
             <a:xfrm>
               <a:off x="7882560" y="2198880"/>
-              <a:ext cx="1292400" cy="1314720"/>
+              <a:ext cx="1292040" cy="1314360"/>
             </a:xfrm>
             <a:prstGeom prst="rect">
               <a:avLst/>
@@ -9464,7 +9464,7 @@
         <p:spPr>
           <a:xfrm>
             <a:off x="548640" y="384120"/>
-            <a:ext cx="9141840" cy="290520"/>
+            <a:ext cx="9141480" cy="290160"/>
           </a:xfrm>
           <a:prstGeom prst="rect">
             <a:avLst/>
@@ -9504,7 +9504,7 @@
               </a:rPr>
               <a:t>TARGET</a:t>
             </a:r>
-            <a:endParaRPr b="0" lang="fr-FR" sz="1200" strike="noStrike" u="none">
+            <a:endParaRPr b="0" lang="en-US" sz="1200" strike="noStrike" u="none">
               <a:solidFill>
                 <a:srgbClr val="000000"/>
               </a:solidFill>
@@ -9524,7 +9524,7 @@
         <p:spPr>
           <a:xfrm>
             <a:off x="548640" y="658440"/>
-            <a:ext cx="11062080" cy="820800"/>
+            <a:ext cx="11061720" cy="820440"/>
           </a:xfrm>
           <a:prstGeom prst="rect">
             <a:avLst/>
@@ -9570,7 +9570,7 @@
               </a:rPr>
               <a:t>This school’s objective</a:t>
             </a:r>
-            <a:endParaRPr b="0" lang="fr-FR" sz="3000" strike="noStrike" u="none">
+            <a:endParaRPr b="0" lang="en-US" sz="3000" strike="noStrike" u="none">
               <a:solidFill>
                 <a:srgbClr val="000000"/>
               </a:solidFill>
@@ -9590,7 +9590,7 @@
         <p:spPr>
           <a:xfrm>
             <a:off x="11185920" y="6446520"/>
-            <a:ext cx="455040" cy="272160"/>
+            <a:ext cx="454680" cy="271800"/>
           </a:xfrm>
           <a:prstGeom prst="rect">
             <a:avLst/>
@@ -9631,7 +9631,7 @@
               </a:rPr>
               <a:t>2</a:t>
             </a:r>
-            <a:endParaRPr b="0" lang="fr-FR" sz="900" strike="noStrike" u="none">
+            <a:endParaRPr b="0" lang="en-US" sz="900" strike="noStrike" u="none">
               <a:solidFill>
                 <a:srgbClr val="000000"/>
               </a:solidFill>
@@ -9651,7 +9651,7 @@
         <p:spPr>
           <a:xfrm>
             <a:off x="540000" y="1480680"/>
-            <a:ext cx="11518560" cy="3015000"/>
+            <a:ext cx="11518200" cy="3015000"/>
           </a:xfrm>
           <a:prstGeom prst="rect">
             <a:avLst/>
@@ -9694,7 +9694,7 @@
               </a:rPr>
               <a:t>Explore how AI can leverage simulated photon and neutron datasets to:</a:t>
             </a:r>
-            <a:endParaRPr b="0" lang="fr-FR" sz="2400" strike="noStrike" u="none">
+            <a:endParaRPr b="0" lang="en-US" sz="2400" strike="noStrike" u="none">
               <a:solidFill>
                 <a:srgbClr val="000000"/>
               </a:solidFill>
@@ -9715,7 +9715,7 @@
                 <a:tab algn="l" pos="0"/>
               </a:tabLst>
             </a:pPr>
-            <a:endParaRPr b="0" lang="fr-FR" sz="2400" strike="noStrike" u="none">
+            <a:endParaRPr b="0" lang="en-US" sz="2400" strike="noStrike" u="none">
               <a:solidFill>
                 <a:srgbClr val="000000"/>
               </a:solidFill>
@@ -9752,7 +9752,7 @@
               </a:rPr>
               <a:t>Solve inverse problems (measurement → parameters)</a:t>
             </a:r>
-            <a:endParaRPr b="0" lang="fr-FR" sz="2400" strike="noStrike" u="none">
+            <a:endParaRPr b="0" lang="en-US" sz="2400" strike="noStrike" u="none">
               <a:solidFill>
                 <a:srgbClr val="000000"/>
               </a:solidFill>
@@ -9789,7 +9789,7 @@
               </a:rPr>
               <a:t>Optimize experiments (find best parameters)</a:t>
             </a:r>
-            <a:endParaRPr b="0" lang="fr-FR" sz="2400" strike="noStrike" u="none">
+            <a:endParaRPr b="0" lang="en-US" sz="2400" strike="noStrike" u="none">
               <a:solidFill>
                 <a:srgbClr val="000000"/>
               </a:solidFill>
@@ -9826,7 +9826,7 @@
               </a:rPr>
               <a:t>Train surrogate models (parameters → measurement)</a:t>
             </a:r>
-            <a:endParaRPr b="0" lang="fr-FR" sz="2400" strike="noStrike" u="none">
+            <a:endParaRPr b="0" lang="en-US" sz="2400" strike="noStrike" u="none">
               <a:solidFill>
                 <a:srgbClr val="000000"/>
               </a:solidFill>
@@ -9847,7 +9847,7 @@
                 <a:tab algn="l" pos="0"/>
               </a:tabLst>
             </a:pPr>
-            <a:endParaRPr b="0" lang="fr-FR" sz="2400" strike="noStrike" u="none">
+            <a:endParaRPr b="0" lang="en-US" sz="2400" strike="noStrike" u="none">
               <a:solidFill>
                 <a:srgbClr val="000000"/>
               </a:solidFill>
@@ -9879,7 +9879,7 @@
               </a:rPr>
               <a:t>For all this, we encourage you to use AI chats/agents.</a:t>
             </a:r>
-            <a:endParaRPr b="0" lang="fr-FR" sz="2400" strike="noStrike" u="none">
+            <a:endParaRPr b="0" lang="en-US" sz="2400" strike="noStrike" u="none">
               <a:solidFill>
                 <a:srgbClr val="000000"/>
               </a:solidFill>
@@ -9936,7 +9936,7 @@
         <p:spPr>
           <a:xfrm>
             <a:off x="548640" y="384120"/>
-            <a:ext cx="9141840" cy="290520"/>
+            <a:ext cx="9141480" cy="290160"/>
           </a:xfrm>
           <a:prstGeom prst="rect">
             <a:avLst/>
@@ -9976,7 +9976,7 @@
               </a:rPr>
               <a:t>X/n</a:t>
             </a:r>
-            <a:endParaRPr b="0" lang="fr-FR" sz="1200" strike="noStrike" u="none">
+            <a:endParaRPr b="0" lang="en-US" sz="1200" strike="noStrike" u="none">
               <a:solidFill>
                 <a:srgbClr val="000000"/>
               </a:solidFill>
@@ -9996,7 +9996,7 @@
         <p:spPr>
           <a:xfrm>
             <a:off x="548640" y="658440"/>
-            <a:ext cx="11062080" cy="820800"/>
+            <a:ext cx="11061720" cy="820440"/>
           </a:xfrm>
           <a:prstGeom prst="rect">
             <a:avLst/>
@@ -10042,7 +10042,7 @@
               </a:rPr>
               <a:t>Why "Photons and Neutrons"?</a:t>
             </a:r>
-            <a:endParaRPr b="0" lang="fr-FR" sz="3000" strike="noStrike" u="none">
+            <a:endParaRPr b="0" lang="en-US" sz="3000" strike="noStrike" u="none">
               <a:solidFill>
                 <a:srgbClr val="000000"/>
               </a:solidFill>
@@ -10062,7 +10062,7 @@
         <p:spPr>
           <a:xfrm>
             <a:off x="11185920" y="6446520"/>
-            <a:ext cx="455040" cy="272160"/>
+            <a:ext cx="454680" cy="271800"/>
           </a:xfrm>
           <a:prstGeom prst="rect">
             <a:avLst/>
@@ -10103,7 +10103,7 @@
               </a:rPr>
               <a:t>2</a:t>
             </a:r>
-            <a:endParaRPr b="0" lang="fr-FR" sz="900" strike="noStrike" u="none">
+            <a:endParaRPr b="0" lang="en-US" sz="900" strike="noStrike" u="none">
               <a:solidFill>
                 <a:srgbClr val="000000"/>
               </a:solidFill>
@@ -10123,7 +10123,7 @@
         <p:spPr>
           <a:xfrm>
             <a:off x="476280" y="1930680"/>
-            <a:ext cx="11238120" cy="3381480"/>
+            <a:ext cx="11237760" cy="3381480"/>
           </a:xfrm>
           <a:prstGeom prst="rect">
             <a:avLst/>
@@ -10160,7 +10160,7 @@
               </a:rPr>
               <a:t>Shared X/n Physics and Simulation Capabilities</a:t>
             </a:r>
-            <a:endParaRPr b="0" lang="fr-FR" sz="2400" strike="noStrike" u="none">
+            <a:endParaRPr b="0" lang="en-US" sz="2400" strike="noStrike" u="none">
               <a:solidFill>
                 <a:srgbClr val="000000"/>
               </a:solidFill>
@@ -10175,7 +10175,7 @@
                 <a:spcPct val="100000"/>
               </a:lnSpc>
             </a:pPr>
-            <a:endParaRPr b="0" lang="fr-FR" sz="2400" strike="noStrike" u="none">
+            <a:endParaRPr b="0" lang="en-US" sz="2400" strike="noStrike" u="none">
               <a:solidFill>
                 <a:srgbClr val="000000"/>
               </a:solidFill>
@@ -10215,7 +10215,7 @@
             <a:br>
               <a:rPr sz="2400"/>
             </a:br>
-            <a:endParaRPr b="0" lang="fr-FR" sz="2400" strike="noStrike" u="none">
+            <a:endParaRPr b="0" lang="en-US" sz="2400" strike="noStrike" u="none">
               <a:solidFill>
                 <a:srgbClr val="000000"/>
               </a:solidFill>
@@ -10257,7 +10257,7 @@
               </a:rPr>
               <a:t>: Energy transfer to the material (e.g., photoelectric effect for X-rays, neutron capture).</a:t>
             </a:r>
-            <a:endParaRPr b="0" lang="fr-FR" sz="2100" strike="noStrike" u="none">
+            <a:endParaRPr b="0" lang="en-US" sz="2100" strike="noStrike" u="none">
               <a:solidFill>
                 <a:srgbClr val="000000"/>
               </a:solidFill>
@@ -10299,7 +10299,7 @@
               </a:rPr>
               <a:t>:</a:t>
             </a:r>
-            <a:endParaRPr b="0" lang="fr-FR" sz="2100" strike="noStrike" u="none">
+            <a:endParaRPr b="0" lang="en-US" sz="2100" strike="noStrike" u="none">
               <a:solidFill>
                 <a:srgbClr val="000000"/>
               </a:solidFill>
@@ -10341,7 +10341,7 @@
               </a:rPr>
               <a:t>: Structure analysis (e.g., Bragg diffraction for X-rays, neutron diffraction).</a:t>
             </a:r>
-            <a:endParaRPr b="0" lang="fr-FR" sz="1800" strike="noStrike" u="none">
+            <a:endParaRPr b="0" lang="en-US" sz="1800" strike="noStrike" u="none">
               <a:solidFill>
                 <a:srgbClr val="000000"/>
               </a:solidFill>
@@ -10383,7 +10383,7 @@
               </a:rPr>
               <a:t>: Dynamics analysis (e.g., Raman scattering for X-rays, neutron inelastic scattering).</a:t>
             </a:r>
-            <a:endParaRPr b="0" lang="fr-FR" sz="1800" strike="noStrike" u="none">
+            <a:endParaRPr b="0" lang="en-US" sz="1800" strike="noStrike" u="none">
               <a:solidFill>
                 <a:srgbClr val="000000"/>
               </a:solidFill>
@@ -10425,7 +10425,7 @@
               </a:rPr>
               <a:t>: Time-resolved studies (e.g., fluorescence, neutron activation).</a:t>
             </a:r>
-            <a:endParaRPr b="0" lang="fr-FR" sz="2100" strike="noStrike" u="none">
+            <a:endParaRPr b="0" lang="en-US" sz="2100" strike="noStrike" u="none">
               <a:solidFill>
                 <a:srgbClr val="000000"/>
               </a:solidFill>
@@ -10482,7 +10482,7 @@
         <p:spPr>
           <a:xfrm>
             <a:off x="548640" y="384120"/>
-            <a:ext cx="9141840" cy="290520"/>
+            <a:ext cx="9141480" cy="290160"/>
           </a:xfrm>
           <a:prstGeom prst="rect">
             <a:avLst/>
@@ -10522,7 +10522,7 @@
               </a:rPr>
               <a:t>X/n</a:t>
             </a:r>
-            <a:endParaRPr b="0" lang="fr-FR" sz="1200" strike="noStrike" u="none">
+            <a:endParaRPr b="0" lang="en-US" sz="1200" strike="noStrike" u="none">
               <a:solidFill>
                 <a:srgbClr val="000000"/>
               </a:solidFill>
@@ -10542,7 +10542,7 @@
         <p:spPr>
           <a:xfrm>
             <a:off x="548640" y="658440"/>
-            <a:ext cx="11062080" cy="820800"/>
+            <a:ext cx="11061720" cy="820440"/>
           </a:xfrm>
           <a:prstGeom prst="rect">
             <a:avLst/>
@@ -10588,7 +10588,7 @@
               </a:rPr>
               <a:t>Why "Photons and Neutrons"?</a:t>
             </a:r>
-            <a:endParaRPr b="0" lang="fr-FR" sz="3000" strike="noStrike" u="none">
+            <a:endParaRPr b="0" lang="en-US" sz="3000" strike="noStrike" u="none">
               <a:solidFill>
                 <a:srgbClr val="000000"/>
               </a:solidFill>
@@ -10608,7 +10608,7 @@
         <p:spPr>
           <a:xfrm>
             <a:off x="11185920" y="6446520"/>
-            <a:ext cx="455040" cy="272160"/>
+            <a:ext cx="454680" cy="271800"/>
           </a:xfrm>
           <a:prstGeom prst="rect">
             <a:avLst/>
@@ -10649,7 +10649,7 @@
               </a:rPr>
               <a:t>2</a:t>
             </a:r>
-            <a:endParaRPr b="0" lang="fr-FR" sz="900" strike="noStrike" u="none">
+            <a:endParaRPr b="0" lang="en-US" sz="900" strike="noStrike" u="none">
               <a:solidFill>
                 <a:srgbClr val="000000"/>
               </a:solidFill>
@@ -10669,7 +10669,7 @@
         <p:spPr>
           <a:xfrm>
             <a:off x="540000" y="1800000"/>
-            <a:ext cx="11117880" cy="4493880"/>
+            <a:ext cx="11117520" cy="4493880"/>
           </a:xfrm>
           <a:prstGeom prst="rect">
             <a:avLst/>
@@ -10723,7 +10723,7 @@
               </a:rPr>
               <a:t>:</a:t>
             </a:r>
-            <a:endParaRPr b="0" lang="fr-FR" sz="2400" strike="noStrike" u="none">
+            <a:endParaRPr b="0" lang="en-US" sz="2400" strike="noStrike" u="none">
               <a:solidFill>
                 <a:srgbClr val="000000"/>
               </a:solidFill>
@@ -10760,7 +10760,7 @@
               </a:rPr>
               <a:t>Parameters → [Instrument] → “Measurement”</a:t>
             </a:r>
-            <a:endParaRPr b="0" lang="fr-FR" sz="2100" strike="noStrike" u="none">
+            <a:endParaRPr b="0" lang="en-US" sz="2100" strike="noStrike" u="none">
               <a:solidFill>
                 <a:srgbClr val="000000"/>
               </a:solidFill>
@@ -10781,7 +10781,7 @@
                 <a:tab algn="l" pos="0"/>
               </a:tabLst>
             </a:pPr>
-            <a:endParaRPr b="0" lang="fr-FR" sz="2100" strike="noStrike" u="none">
+            <a:endParaRPr b="0" lang="en-US" sz="2100" strike="noStrike" u="none">
               <a:solidFill>
                 <a:srgbClr val="000000"/>
               </a:solidFill>
@@ -10821,7 +10821,7 @@
               </a:rPr>
               <a:t>:</a:t>
             </a:r>
-            <a:endParaRPr b="0" lang="fr-FR" sz="2400" strike="noStrike" u="none">
+            <a:endParaRPr b="0" lang="en-US" sz="2400" strike="noStrike" u="none">
               <a:solidFill>
                 <a:srgbClr val="000000"/>
               </a:solidFill>
@@ -10866,7 +10866,7 @@
               </a:rPr>
               <a:t>: Monte Carlo simulator for neutron scattering instruments.</a:t>
             </a:r>
-            <a:endParaRPr b="0" lang="fr-FR" sz="2100" strike="noStrike" u="none">
+            <a:endParaRPr b="0" lang="en-US" sz="2100" strike="noStrike" u="none">
               <a:solidFill>
                 <a:srgbClr val="000000"/>
               </a:solidFill>
@@ -10911,7 +10911,7 @@
               </a:rPr>
               <a:t>: Monte Carlo simulator for X-ray instruments.</a:t>
             </a:r>
-            <a:endParaRPr b="0" lang="fr-FR" sz="2100" strike="noStrike" u="none">
+            <a:endParaRPr b="0" lang="en-US" sz="2100" strike="noStrike" u="none">
               <a:solidFill>
                 <a:srgbClr val="000000"/>
               </a:solidFill>
@@ -10945,7 +10945,7 @@
               </a:rPr>
               <a:t>Both enable realistic modeling of beamlines, detectors, and sample interactions.</a:t>
             </a:r>
-            <a:endParaRPr b="0" lang="fr-FR" sz="2100" strike="noStrike" u="none">
+            <a:endParaRPr b="0" lang="en-US" sz="2100" strike="noStrike" u="none">
               <a:solidFill>
                 <a:srgbClr val="000000"/>
               </a:solidFill>
@@ -10963,7 +10963,7 @@
                 <a:tab algn="l" pos="0"/>
               </a:tabLst>
             </a:pPr>
-            <a:endParaRPr b="0" lang="fr-FR" sz="2100" strike="noStrike" u="none">
+            <a:endParaRPr b="0" lang="en-US" sz="2100" strike="noStrike" u="none">
               <a:solidFill>
                 <a:srgbClr val="000000"/>
               </a:solidFill>
@@ -11003,7 +11003,7 @@
               </a:rPr>
               <a:t>:</a:t>
             </a:r>
-            <a:endParaRPr b="0" lang="fr-FR" sz="2400" strike="noStrike" u="none">
+            <a:endParaRPr b="0" lang="en-US" sz="2400" strike="noStrike" u="none">
               <a:solidFill>
                 <a:srgbClr val="000000"/>
               </a:solidFill>
@@ -11048,7 +11048,7 @@
               </a:rPr>
               <a:t>: Capture complex instrument geometries and material responses.</a:t>
             </a:r>
-            <a:endParaRPr b="0" lang="fr-FR" sz="2100" strike="noStrike" u="none">
+            <a:endParaRPr b="0" lang="en-US" sz="2100" strike="noStrike" u="none">
               <a:solidFill>
                 <a:srgbClr val="000000"/>
               </a:solidFill>
@@ -11093,7 +11093,7 @@
               </a:rPr>
               <a:t>: Test hypothetical setups.</a:t>
             </a:r>
-            <a:endParaRPr b="0" lang="fr-FR" sz="2100" strike="noStrike" u="none">
+            <a:endParaRPr b="0" lang="en-US" sz="2100" strike="noStrike" u="none">
               <a:solidFill>
                 <a:srgbClr val="000000"/>
               </a:solidFill>
@@ -11138,7 +11138,7 @@
               </a:rPr>
               <a:t>: Avoid expensive trial-and-error on real instruments/BL.</a:t>
             </a:r>
-            <a:endParaRPr b="0" lang="fr-FR" sz="2100" strike="noStrike" u="none">
+            <a:endParaRPr b="0" lang="en-US" sz="2100" strike="noStrike" u="none">
               <a:solidFill>
                 <a:srgbClr val="000000"/>
               </a:solidFill>
@@ -11156,7 +11156,7 @@
                 <a:tab algn="l" pos="0"/>
               </a:tabLst>
             </a:pPr>
-            <a:endParaRPr b="0" lang="fr-FR" sz="2100" strike="noStrike" u="none">
+            <a:endParaRPr b="0" lang="en-US" sz="2100" strike="noStrike" u="none">
               <a:solidFill>
                 <a:srgbClr val="000000"/>
               </a:solidFill>
@@ -11213,7 +11213,7 @@
         <p:spPr>
           <a:xfrm>
             <a:off x="548640" y="384120"/>
-            <a:ext cx="9141840" cy="290520"/>
+            <a:ext cx="9141480" cy="290160"/>
           </a:xfrm>
           <a:prstGeom prst="rect">
             <a:avLst/>
@@ -11253,7 +11253,7 @@
               </a:rPr>
               <a:t>Realistic datasets</a:t>
             </a:r>
-            <a:endParaRPr b="0" lang="fr-FR" sz="1200" strike="noStrike" u="none">
+            <a:endParaRPr b="0" lang="en-US" sz="1200" strike="noStrike" u="none">
               <a:solidFill>
                 <a:srgbClr val="000000"/>
               </a:solidFill>
@@ -11273,7 +11273,7 @@
         <p:spPr>
           <a:xfrm>
             <a:off x="548640" y="658440"/>
-            <a:ext cx="11062080" cy="820800"/>
+            <a:ext cx="11061720" cy="820440"/>
           </a:xfrm>
           <a:prstGeom prst="rect">
             <a:avLst/>
@@ -11319,7 +11319,7 @@
               </a:rPr>
               <a:t>Why Realistic AI Datasets?</a:t>
             </a:r>
-            <a:endParaRPr b="0" lang="fr-FR" sz="3000" strike="noStrike" u="none">
+            <a:endParaRPr b="0" lang="en-US" sz="3000" strike="noStrike" u="none">
               <a:solidFill>
                 <a:srgbClr val="000000"/>
               </a:solidFill>
@@ -11339,7 +11339,7 @@
         <p:spPr>
           <a:xfrm>
             <a:off x="11185920" y="6446520"/>
-            <a:ext cx="455040" cy="272160"/>
+            <a:ext cx="454680" cy="271800"/>
           </a:xfrm>
           <a:prstGeom prst="rect">
             <a:avLst/>
@@ -11380,7 +11380,7 @@
               </a:rPr>
               <a:t>2</a:t>
             </a:r>
-            <a:endParaRPr b="0" lang="fr-FR" sz="900" strike="noStrike" u="none">
+            <a:endParaRPr b="0" lang="en-US" sz="900" strike="noStrike" u="none">
               <a:solidFill>
                 <a:srgbClr val="000000"/>
               </a:solidFill>
@@ -11400,7 +11400,7 @@
         <p:spPr>
           <a:xfrm>
             <a:off x="540000" y="1800000"/>
-            <a:ext cx="10660680" cy="3807720"/>
+            <a:ext cx="10660320" cy="3807720"/>
           </a:xfrm>
           <a:prstGeom prst="rect">
             <a:avLst/>
@@ -11446,7 +11446,7 @@
             <a:br>
               <a:rPr sz="2400"/>
             </a:br>
-            <a:endParaRPr b="0" lang="fr-FR" sz="2400" strike="noStrike" u="none">
+            <a:endParaRPr b="0" lang="en-US" sz="2400" strike="noStrike" u="none">
               <a:solidFill>
                 <a:srgbClr val="000000"/>
               </a:solidFill>
@@ -11494,7 +11494,7 @@
               </a:rPr>
               <a:t>:</a:t>
             </a:r>
-            <a:endParaRPr b="0" lang="fr-FR" sz="2400" strike="noStrike" u="none">
+            <a:endParaRPr b="0" lang="en-US" sz="2400" strike="noStrike" u="none">
               <a:solidFill>
                 <a:srgbClr val="000000"/>
               </a:solidFill>
@@ -11531,7 +11531,7 @@
               </a:rPr>
               <a:t>Raw data often lacks metadata (e.g., sample composition, instrument settings).</a:t>
             </a:r>
-            <a:endParaRPr b="0" lang="fr-FR" sz="2100" strike="noStrike" u="none">
+            <a:endParaRPr b="0" lang="en-US" sz="2100" strike="noStrike" u="none">
               <a:solidFill>
                 <a:srgbClr val="000000"/>
               </a:solidFill>
@@ -11582,7 +11582,7 @@
               </a:rPr>
               <a:t> </a:t>
             </a:r>
-            <a:endParaRPr b="0" lang="fr-FR" sz="2100" strike="noStrike" u="none">
+            <a:endParaRPr b="0" lang="en-US" sz="2100" strike="noStrike" u="none">
               <a:solidFill>
                 <a:srgbClr val="000000"/>
               </a:solidFill>
@@ -11630,7 +11630,7 @@
               </a:rPr>
               <a:t>:</a:t>
             </a:r>
-            <a:endParaRPr b="0" lang="fr-FR" sz="2400" strike="noStrike" u="none">
+            <a:endParaRPr b="0" lang="en-US" sz="2400" strike="noStrike" u="none">
               <a:solidFill>
                 <a:srgbClr val="000000"/>
               </a:solidFill>
@@ -11667,7 +11667,7 @@
               </a:rPr>
               <a:t>Publications describe experimental conditions, but formats vary widely.</a:t>
             </a:r>
-            <a:endParaRPr b="0" lang="fr-FR" sz="2100" strike="noStrike" u="none">
+            <a:endParaRPr b="0" lang="en-US" sz="2100" strike="noStrike" u="none">
               <a:solidFill>
                 <a:srgbClr val="000000"/>
               </a:solidFill>
@@ -11704,7 +11704,7 @@
               </a:rPr>
               <a:t>Not machine-readable or standardized for AI training.</a:t>
             </a:r>
-            <a:endParaRPr b="0" lang="fr-FR" sz="2100" strike="noStrike" u="none">
+            <a:endParaRPr b="0" lang="en-US" sz="2100" strike="noStrike" u="none">
               <a:solidFill>
                 <a:srgbClr val="000000"/>
               </a:solidFill>
@@ -11761,7 +11761,7 @@
         <p:spPr>
           <a:xfrm>
             <a:off x="548640" y="384120"/>
-            <a:ext cx="9141840" cy="290520"/>
+            <a:ext cx="9141480" cy="290160"/>
           </a:xfrm>
           <a:prstGeom prst="rect">
             <a:avLst/>
@@ -11801,7 +11801,7 @@
               </a:rPr>
               <a:t>Realistic datasets</a:t>
             </a:r>
-            <a:endParaRPr b="0" lang="fr-FR" sz="1200" strike="noStrike" u="none">
+            <a:endParaRPr b="0" lang="en-US" sz="1200" strike="noStrike" u="none">
               <a:solidFill>
                 <a:srgbClr val="000000"/>
               </a:solidFill>
@@ -11821,7 +11821,7 @@
         <p:spPr>
           <a:xfrm>
             <a:off x="548640" y="658440"/>
-            <a:ext cx="11062080" cy="820800"/>
+            <a:ext cx="11061720" cy="820440"/>
           </a:xfrm>
           <a:prstGeom prst="rect">
             <a:avLst/>
@@ -11867,7 +11867,7 @@
               </a:rPr>
               <a:t>Why Realistic AI Datasets?</a:t>
             </a:r>
-            <a:endParaRPr b="0" lang="fr-FR" sz="3000" strike="noStrike" u="none">
+            <a:endParaRPr b="0" lang="en-US" sz="3000" strike="noStrike" u="none">
               <a:solidFill>
                 <a:srgbClr val="000000"/>
               </a:solidFill>
@@ -11887,7 +11887,7 @@
         <p:spPr>
           <a:xfrm>
             <a:off x="11185920" y="6446520"/>
-            <a:ext cx="455040" cy="272160"/>
+            <a:ext cx="454680" cy="271800"/>
           </a:xfrm>
           <a:prstGeom prst="rect">
             <a:avLst/>
@@ -11928,7 +11928,7 @@
               </a:rPr>
               <a:t>2</a:t>
             </a:r>
-            <a:endParaRPr b="0" lang="fr-FR" sz="900" strike="noStrike" u="none">
+            <a:endParaRPr b="0" lang="en-US" sz="900" strike="noStrike" u="none">
               <a:solidFill>
                 <a:srgbClr val="000000"/>
               </a:solidFill>
@@ -11948,7 +11948,7 @@
         <p:spPr>
           <a:xfrm>
             <a:off x="540000" y="1800000"/>
-            <a:ext cx="9475920" cy="4660920"/>
+            <a:ext cx="9475560" cy="4660920"/>
           </a:xfrm>
           <a:prstGeom prst="rect">
             <a:avLst/>
@@ -11994,7 +11994,7 @@
             <a:br>
               <a:rPr sz="2400"/>
             </a:br>
-            <a:endParaRPr b="0" lang="fr-FR" sz="2400" strike="noStrike" u="none">
+            <a:endParaRPr b="0" lang="en-US" sz="2400" strike="noStrike" u="none">
               <a:solidFill>
                 <a:srgbClr val="000000"/>
               </a:solidFill>
@@ -12042,7 +12042,7 @@
               </a:rPr>
               <a:t>:</a:t>
             </a:r>
-            <a:endParaRPr b="0" lang="fr-FR" sz="2400" strike="noStrike" u="none">
+            <a:endParaRPr b="0" lang="en-US" sz="2400" strike="noStrike" u="none">
               <a:solidFill>
                 <a:srgbClr val="000000"/>
               </a:solidFill>
@@ -12079,7 +12079,7 @@
               </a:rPr>
               <a:t>Every input (e.g., sample thickness, detector angle) is known and adjustable.</a:t>
             </a:r>
-            <a:endParaRPr b="0" lang="fr-FR" sz="2100" strike="noStrike" u="none">
+            <a:endParaRPr b="0" lang="en-US" sz="2100" strike="noStrike" u="none">
               <a:solidFill>
                 <a:srgbClr val="000000"/>
               </a:solidFill>
@@ -12116,7 +12116,7 @@
               </a:rPr>
               <a:t>Outputs (e.g., scattering patterns, spectra) are directly linked to inputs.</a:t>
             </a:r>
-            <a:endParaRPr b="0" lang="fr-FR" sz="2100" strike="noStrike" u="none">
+            <a:endParaRPr b="0" lang="en-US" sz="2100" strike="noStrike" u="none">
               <a:solidFill>
                 <a:srgbClr val="000000"/>
               </a:solidFill>
@@ -12164,7 +12164,7 @@
               </a:rPr>
               <a:t>:</a:t>
             </a:r>
-            <a:endParaRPr b="0" lang="fr-FR" sz="2400" strike="noStrike" u="none">
+            <a:endParaRPr b="0" lang="en-US" sz="2400" strike="noStrike" u="none">
               <a:solidFill>
                 <a:srgbClr val="000000"/>
               </a:solidFill>
@@ -12185,7 +12185,7 @@
                 <a:tab algn="l" pos="0"/>
               </a:tabLst>
             </a:pPr>
-            <a:endParaRPr b="0" lang="fr-FR" sz="2400" strike="noStrike" u="none">
+            <a:endParaRPr b="0" lang="en-US" sz="2400" strike="noStrike" u="none">
               <a:solidFill>
                 <a:srgbClr val="000000"/>
               </a:solidFill>
@@ -12222,7 +12222,7 @@
               </a:rPr>
               <a:t>Parameters → [Simulation] → Virtual “Measurement”</a:t>
             </a:r>
-            <a:endParaRPr b="0" lang="fr-FR" sz="2100" strike="noStrike" u="none">
+            <a:endParaRPr b="0" lang="en-US" sz="2100" strike="noStrike" u="none">
               <a:solidFill>
                 <a:srgbClr val="000000"/>
               </a:solidFill>
@@ -12243,7 +12243,7 @@
                 <a:tab algn="l" pos="0"/>
               </a:tabLst>
             </a:pPr>
-            <a:endParaRPr b="0" lang="fr-FR" sz="2100" strike="noStrike" u="none">
+            <a:endParaRPr b="0" lang="en-US" sz="2100" strike="noStrike" u="none">
               <a:solidFill>
                 <a:srgbClr val="000000"/>
               </a:solidFill>
@@ -12291,7 +12291,7 @@
               </a:rPr>
               <a:t> </a:t>
             </a:r>
-            <a:endParaRPr b="0" lang="fr-FR" sz="2400" strike="noStrike" u="none">
+            <a:endParaRPr b="0" lang="en-US" sz="2400" strike="noStrike" u="none">
               <a:solidFill>
                 <a:srgbClr val="000000"/>
               </a:solidFill>
@@ -12341,7 +12341,7 @@
         <p:spPr>
           <a:xfrm>
             <a:off x="548640" y="384120"/>
-            <a:ext cx="9141840" cy="290520"/>
+            <a:ext cx="9141480" cy="290160"/>
           </a:xfrm>
           <a:prstGeom prst="rect">
             <a:avLst/>
@@ -12381,7 +12381,7 @@
               </a:rPr>
               <a:t>Realistic datasets</a:t>
             </a:r>
-            <a:endParaRPr b="0" lang="fr-FR" sz="1200" strike="noStrike" u="none">
+            <a:endParaRPr b="0" lang="en-US" sz="1200" strike="noStrike" u="none">
               <a:solidFill>
                 <a:srgbClr val="000000"/>
               </a:solidFill>
@@ -12401,7 +12401,7 @@
         <p:spPr>
           <a:xfrm>
             <a:off x="548640" y="658440"/>
-            <a:ext cx="11062080" cy="820800"/>
+            <a:ext cx="11061720" cy="820440"/>
           </a:xfrm>
           <a:prstGeom prst="rect">
             <a:avLst/>
@@ -12447,7 +12447,7 @@
               </a:rPr>
               <a:t>Why Realistic AI Datasets?</a:t>
             </a:r>
-            <a:endParaRPr b="0" lang="fr-FR" sz="3000" strike="noStrike" u="none">
+            <a:endParaRPr b="0" lang="en-US" sz="3000" strike="noStrike" u="none">
               <a:solidFill>
                 <a:srgbClr val="000000"/>
               </a:solidFill>
@@ -12467,7 +12467,7 @@
         <p:spPr>
           <a:xfrm>
             <a:off x="11185920" y="6446520"/>
-            <a:ext cx="455040" cy="272160"/>
+            <a:ext cx="454680" cy="271800"/>
           </a:xfrm>
           <a:prstGeom prst="rect">
             <a:avLst/>
@@ -12508,7 +12508,7 @@
               </a:rPr>
               <a:t>2</a:t>
             </a:r>
-            <a:endParaRPr b="0" lang="fr-FR" sz="900" strike="noStrike" u="none">
+            <a:endParaRPr b="0" lang="en-US" sz="900" strike="noStrike" u="none">
               <a:solidFill>
                 <a:srgbClr val="000000"/>
               </a:solidFill>
@@ -12526,22 +12526,22 @@
           <p:nvPr/>
         </p:nvGraphicFramePr>
         <p:xfrm>
-          <a:off x="2736000" y="2052000"/>
-          <a:ext cx="5364000" cy="4068000"/>
+          <a:off x="2971800" y="2610360"/>
+          <a:ext cx="8878680" cy="4067640"/>
         </p:xfrm>
         <a:graphic>
           <a:graphicData uri="http://schemas.openxmlformats.org/drawingml/2006/table">
             <a:tbl>
               <a:tblPr/>
               <a:tblGrid>
-                <a:gridCol w="1788120"/>
-                <a:gridCol w="1788120"/>
-                <a:gridCol w="1787760"/>
+                <a:gridCol w="2959200"/>
+                <a:gridCol w="2959200"/>
+                <a:gridCol w="2960280"/>
               </a:tblGrid>
               <a:tr h="1355760">
                 <a:tc>
                   <a:txBody>
-                    <a:bodyPr lIns="36000" rIns="36000" tIns="36000" bIns="36000" anchor="t">
+                    <a:bodyPr lIns="36000" rIns="36000" anchor="t">
                       <a:noAutofit/>
                     </a:bodyPr>
                     <a:p>
@@ -12587,10 +12587,15 @@
                 </a:tc>
                 <a:tc>
                   <a:txBody>
-                    <a:bodyPr lIns="36000" rIns="36000" tIns="36000" bIns="36000" anchor="t">
+                    <a:bodyPr lIns="36000" rIns="36000" anchor="t">
                       <a:noAutofit/>
                     </a:bodyPr>
                     <a:p>
+                      <a:pPr>
+                        <a:lnSpc>
+                          <a:spcPct val="100000"/>
+                        </a:lnSpc>
+                      </a:pPr>
                       <a:r>
                         <a:rPr b="1" lang="fr-FR" sz="1800" strike="noStrike" u="none">
                           <a:solidFill>
@@ -12602,7 +12607,7 @@
                         </a:rPr>
                         <a:t>Input X=Parameters</a:t>
                       </a:r>
-                      <a:endParaRPr b="1" lang="fr-FR" sz="1800" strike="noStrike" u="none">
+                      <a:endParaRPr b="0" lang="en-US" sz="1800" strike="noStrike" u="none">
                         <a:solidFill>
                           <a:srgbClr val="000000"/>
                         </a:solidFill>
@@ -12613,8 +12618,9 @@
                     </a:p>
                   </a:txBody>
                   <a:tcPr anchor="t" marL="36000" marR="36000">
-                    <a:lnL>
+                    <a:lnL w="12240">
                       <a:noFill/>
+                      <a:prstDash val="solid"/>
                     </a:lnL>
                     <a:lnR w="7200">
                       <a:solidFill>
@@ -12641,10 +12647,15 @@
                 </a:tc>
                 <a:tc>
                   <a:txBody>
-                    <a:bodyPr lIns="36000" rIns="36000" tIns="36000" bIns="36000" anchor="t">
+                    <a:bodyPr lIns="36000" rIns="36000" anchor="t">
                       <a:noAutofit/>
                     </a:bodyPr>
                     <a:p>
+                      <a:pPr>
+                        <a:lnSpc>
+                          <a:spcPct val="100000"/>
+                        </a:lnSpc>
+                      </a:pPr>
                       <a:r>
                         <a:rPr b="1" lang="fr-FR" sz="1800" strike="noStrike" u="none">
                           <a:solidFill>
@@ -12656,7 +12667,7 @@
                         </a:rPr>
                         <a:t>Input X=Measurements</a:t>
                       </a:r>
-                      <a:endParaRPr b="1" lang="fr-FR" sz="1800" strike="noStrike" u="none">
+                      <a:endParaRPr b="0" lang="en-US" sz="1800" strike="noStrike" u="none">
                         <a:solidFill>
                           <a:srgbClr val="000000"/>
                         </a:solidFill>
@@ -12700,10 +12711,15 @@
               <a:tr h="1355760">
                 <a:tc>
                   <a:txBody>
-                    <a:bodyPr lIns="36000" rIns="36000" tIns="36000" bIns="36000" anchor="t">
+                    <a:bodyPr lIns="36000" rIns="36000" anchor="t">
                       <a:noAutofit/>
                     </a:bodyPr>
                     <a:p>
+                      <a:pPr>
+                        <a:lnSpc>
+                          <a:spcPct val="100000"/>
+                        </a:lnSpc>
+                      </a:pPr>
                       <a:r>
                         <a:rPr b="1" lang="fr-FR" sz="1800" strike="noStrike" u="none">
                           <a:solidFill>
@@ -12715,7 +12731,7 @@
                         </a:rPr>
                         <a:t>Output Y=Parameters</a:t>
                       </a:r>
-                      <a:endParaRPr b="1" lang="fr-FR" sz="1800" strike="noStrike" u="none">
+                      <a:endParaRPr b="0" lang="en-US" sz="1800" strike="noStrike" u="none">
                         <a:solidFill>
                           <a:srgbClr val="000000"/>
                         </a:solidFill>
@@ -12738,8 +12754,9 @@
                       </a:solidFill>
                       <a:prstDash val="solid"/>
                     </a:lnR>
-                    <a:lnT>
+                    <a:lnT w="12240">
                       <a:noFill/>
+                      <a:prstDash val="solid"/>
                     </a:lnT>
                     <a:lnB w="7200">
                       <a:solidFill>
@@ -12754,11 +12771,15 @@
                 </a:tc>
                 <a:tc>
                   <a:txBody>
-                    <a:bodyPr lIns="36000" rIns="36000" tIns="36000" bIns="36000" anchor="t">
+                    <a:bodyPr lIns="36000" rIns="36000" anchor="t">
                       <a:noAutofit/>
                     </a:bodyPr>
                     <a:p>
-                      <a:pPr algn="ctr"/>
+                      <a:pPr algn="ctr">
+                        <a:lnSpc>
+                          <a:spcPct val="100000"/>
+                        </a:lnSpc>
+                      </a:pPr>
                       <a:r>
                         <a:rPr b="0" lang="fr-FR" sz="1800" strike="noStrike" u="none">
                           <a:solidFill>
@@ -12770,7 +12791,7 @@
                         </a:rPr>
                         <a:t>Optimisation</a:t>
                       </a:r>
-                      <a:endParaRPr b="0" lang="fr-FR" sz="1800" strike="noStrike" u="none">
+                      <a:endParaRPr b="0" lang="en-US" sz="1800" strike="noStrike" u="none">
                         <a:solidFill>
                           <a:srgbClr val="000000"/>
                         </a:solidFill>
@@ -12781,8 +12802,9 @@
                     </a:p>
                   </a:txBody>
                   <a:tcPr anchor="t" marL="36000" marR="36000">
-                    <a:lnL>
+                    <a:lnL w="12240">
                       <a:noFill/>
+                      <a:prstDash val="solid"/>
                     </a:lnL>
                     <a:lnR w="7200">
                       <a:solidFill>
@@ -12790,8 +12812,9 @@
                       </a:solidFill>
                       <a:prstDash val="solid"/>
                     </a:lnR>
-                    <a:lnT>
+                    <a:lnT w="12240">
                       <a:noFill/>
+                      <a:prstDash val="solid"/>
                     </a:lnT>
                     <a:lnB w="7200">
                       <a:solidFill>
@@ -12804,11 +12827,15 @@
                 </a:tc>
                 <a:tc>
                   <a:txBody>
-                    <a:bodyPr lIns="36000" rIns="36000" tIns="36000" bIns="36000" anchor="t">
+                    <a:bodyPr lIns="36000" rIns="36000" anchor="t">
                       <a:noAutofit/>
                     </a:bodyPr>
                     <a:p>
-                      <a:pPr algn="ctr"/>
+                      <a:pPr algn="ctr">
+                        <a:lnSpc>
+                          <a:spcPct val="100000"/>
+                        </a:lnSpc>
+                      </a:pPr>
                       <a:r>
                         <a:rPr b="0" lang="fr-FR" sz="1800" strike="noStrike" u="none">
                           <a:solidFill>
@@ -12820,7 +12847,7 @@
                         </a:rPr>
                         <a:t>Inverse problem</a:t>
                       </a:r>
-                      <a:endParaRPr b="0" lang="fr-FR" sz="1800" strike="noStrike" u="none">
+                      <a:endParaRPr b="0" lang="en-US" sz="1800" strike="noStrike" u="none">
                         <a:solidFill>
                           <a:srgbClr val="000000"/>
                         </a:solidFill>
@@ -12843,8 +12870,9 @@
                       </a:solidFill>
                       <a:prstDash val="solid"/>
                     </a:lnR>
-                    <a:lnT>
+                    <a:lnT w="12240">
                       <a:noFill/>
+                      <a:prstDash val="solid"/>
                     </a:lnT>
                     <a:lnB w="7200">
                       <a:solidFill>
@@ -12859,10 +12887,15 @@
               <a:tr h="1356480">
                 <a:tc>
                   <a:txBody>
-                    <a:bodyPr lIns="36000" rIns="36000" tIns="36000" bIns="36000" anchor="t">
+                    <a:bodyPr lIns="36000" rIns="36000" anchor="t">
                       <a:noAutofit/>
                     </a:bodyPr>
                     <a:p>
+                      <a:pPr>
+                        <a:lnSpc>
+                          <a:spcPct val="100000"/>
+                        </a:lnSpc>
+                      </a:pPr>
                       <a:r>
                         <a:rPr b="1" lang="fr-FR" sz="1800" strike="noStrike" u="none">
                           <a:solidFill>
@@ -12874,7 +12907,7 @@
                         </a:rPr>
                         <a:t>Output Y=Measurements</a:t>
                       </a:r>
-                      <a:endParaRPr b="1" lang="fr-FR" sz="1800" strike="noStrike" u="none">
+                      <a:endParaRPr b="0" lang="en-US" sz="1800" strike="noStrike" u="none">
                         <a:solidFill>
                           <a:srgbClr val="000000"/>
                         </a:solidFill>
@@ -12916,11 +12949,15 @@
                 </a:tc>
                 <a:tc>
                   <a:txBody>
-                    <a:bodyPr lIns="36000" rIns="36000" tIns="36000" bIns="36000" anchor="t">
+                    <a:bodyPr lIns="36000" rIns="36000" anchor="t">
                       <a:noAutofit/>
                     </a:bodyPr>
                     <a:p>
-                      <a:pPr algn="ctr"/>
+                      <a:pPr algn="ctr">
+                        <a:lnSpc>
+                          <a:spcPct val="100000"/>
+                        </a:lnSpc>
+                      </a:pPr>
                       <a:r>
                         <a:rPr b="0" lang="fr-FR" sz="1800" strike="noStrike" u="none">
                           <a:solidFill>
@@ -12932,7 +12969,7 @@
                         </a:rPr>
                         <a:t>Simulation, Surrogate</a:t>
                       </a:r>
-                      <a:endParaRPr b="0" lang="fr-FR" sz="1800" strike="noStrike" u="none">
+                      <a:endParaRPr b="0" lang="en-US" sz="1800" strike="noStrike" u="none">
                         <a:solidFill>
                           <a:srgbClr val="000000"/>
                         </a:solidFill>
@@ -12943,8 +12980,9 @@
                     </a:p>
                   </a:txBody>
                   <a:tcPr anchor="t" marL="36000" marR="36000">
-                    <a:lnL>
+                    <a:lnL w="12240">
                       <a:noFill/>
+                      <a:prstDash val="solid"/>
                     </a:lnL>
                     <a:lnR w="7200">
                       <a:solidFill>
@@ -12969,11 +13007,15 @@
                 </a:tc>
                 <a:tc>
                   <a:txBody>
-                    <a:bodyPr lIns="36000" rIns="36000" tIns="36000" bIns="36000" anchor="t">
+                    <a:bodyPr lIns="36000" rIns="36000" anchor="t">
                       <a:noAutofit/>
                     </a:bodyPr>
                     <a:p>
-                      <a:pPr algn="ctr"/>
+                      <a:pPr algn="ctr">
+                        <a:lnSpc>
+                          <a:spcPct val="100000"/>
+                        </a:lnSpc>
+                      </a:pPr>
                       <a:r>
                         <a:rPr b="0" lang="fr-FR" sz="1800" strike="noStrike" u="none">
                           <a:solidFill>
@@ -12983,9 +13025,9 @@
                           <a:uFillTx/>
                           <a:latin typeface="Arial"/>
                         </a:rPr>
-                        <a:t>De-noising, de-convolution</a:t>
+                        <a:t>De-noising, de-convolution, segmentation</a:t>
                       </a:r>
-                      <a:endParaRPr b="0" lang="fr-FR" sz="1800" strike="noStrike" u="none">
+                      <a:endParaRPr b="0" lang="en-US" sz="1800" strike="noStrike" u="none">
                         <a:solidFill>
                           <a:srgbClr val="000000"/>
                         </a:solidFill>
@@ -13028,6 +13070,113 @@
           </a:graphicData>
         </a:graphic>
       </p:graphicFrame>
+      <p:sp>
+        <p:nvSpPr>
+          <p:cNvPr id="65" name=""/>
+          <p:cNvSpPr/>
+          <p:nvPr/>
+        </p:nvSpPr>
+        <p:spPr>
+          <a:xfrm>
+            <a:off x="540000" y="1800000"/>
+            <a:ext cx="9475560" cy="1111320"/>
+          </a:xfrm>
+          <a:prstGeom prst="rect">
+            <a:avLst/>
+          </a:prstGeom>
+          <a:noFill/>
+          <a:ln w="0">
+            <a:noFill/>
+          </a:ln>
+        </p:spPr>
+        <p:style>
+          <a:lnRef idx="0"/>
+          <a:fillRef idx="0"/>
+          <a:effectRef idx="0"/>
+          <a:fontRef idx="minor"/>
+        </p:style>
+        <p:txBody>
+          <a:bodyPr lIns="90000" rIns="90000" tIns="45000" bIns="45000" anchor="t">
+            <a:spAutoFit/>
+          </a:bodyPr>
+          <a:p>
+            <a:pPr defTabSz="343080">
+              <a:lnSpc>
+                <a:spcPct val="100000"/>
+              </a:lnSpc>
+              <a:spcBef>
+                <a:spcPts val="2999"/>
+              </a:spcBef>
+              <a:tabLst>
+                <a:tab algn="l" pos="0"/>
+              </a:tabLst>
+            </a:pPr>
+            <a:r>
+              <a:rPr b="1" lang="fr-FR" sz="2100" strike="noStrike" u="none">
+                <a:solidFill>
+                  <a:srgbClr val="ff00ff"/>
+                </a:solidFill>
+                <a:effectLst/>
+                <a:uFillTx/>
+                <a:latin typeface="Courier New"/>
+              </a:rPr>
+              <a:t>Parameters → [Simulation] → Virtual “Measurement”</a:t>
+            </a:r>
+            <a:endParaRPr b="0" lang="en-US" sz="2100" strike="noStrike" u="none">
+              <a:solidFill>
+                <a:srgbClr val="000000"/>
+              </a:solidFill>
+              <a:effectLst/>
+              <a:uFillTx/>
+              <a:latin typeface="Arial"/>
+            </a:endParaRPr>
+          </a:p>
+          <a:p>
+            <a:pPr defTabSz="343080">
+              <a:lnSpc>
+                <a:spcPct val="100000"/>
+              </a:lnSpc>
+              <a:spcBef>
+                <a:spcPts val="2999"/>
+              </a:spcBef>
+              <a:tabLst>
+                <a:tab algn="l" pos="0"/>
+              </a:tabLst>
+            </a:pPr>
+            <a:r>
+              <a:rPr b="0" lang="fr-FR" sz="2100" strike="noStrike" u="none">
+                <a:solidFill>
+                  <a:srgbClr val="ff00ff"/>
+                </a:solidFill>
+                <a:effectLst/>
+                <a:uFillTx/>
+                <a:latin typeface="Arial"/>
+                <a:ea typeface="Unifont"/>
+              </a:rPr>
+              <a:t>X </a:t>
+            </a:r>
+            <a:r>
+              <a:rPr b="1" lang="fr-FR" sz="2100" strike="noStrike" u="none">
+                <a:solidFill>
+                  <a:srgbClr val="ff00ff"/>
+                </a:solidFill>
+                <a:effectLst/>
+                <a:uFillTx/>
+                <a:latin typeface="Courier New"/>
+              </a:rPr>
+              <a:t>→ [AI] → Y</a:t>
+            </a:r>
+            <a:endParaRPr b="0" lang="en-US" sz="2100" strike="noStrike" u="none">
+              <a:solidFill>
+                <a:srgbClr val="000000"/>
+              </a:solidFill>
+              <a:effectLst/>
+              <a:uFillTx/>
+              <a:latin typeface="Arial"/>
+            </a:endParaRPr>
+          </a:p>
+        </p:txBody>
+      </p:sp>
     </p:spTree>
   </p:cSld>
   <mc:AlternateContent>
@@ -13067,14 +13216,14 @@
       </p:grpSpPr>
       <p:sp>
         <p:nvSpPr>
-          <p:cNvPr id="65" name="Text 24"/>
+          <p:cNvPr id="66" name="Text 24"/>
           <p:cNvSpPr/>
           <p:nvPr/>
         </p:nvSpPr>
         <p:spPr>
           <a:xfrm>
             <a:off x="548640" y="384120"/>
-            <a:ext cx="9141840" cy="290520"/>
+            <a:ext cx="9141480" cy="290160"/>
           </a:xfrm>
           <a:prstGeom prst="rect">
             <a:avLst/>
@@ -13114,7 +13263,7 @@
               </a:rPr>
               <a:t>Realistic datasets</a:t>
             </a:r>
-            <a:endParaRPr b="0" lang="fr-FR" sz="1200" strike="noStrike" u="none">
+            <a:endParaRPr b="0" lang="en-US" sz="1200" strike="noStrike" u="none">
               <a:solidFill>
                 <a:srgbClr val="000000"/>
               </a:solidFill>
@@ -13127,14 +13276,14 @@
       </p:sp>
       <p:sp>
         <p:nvSpPr>
-          <p:cNvPr id="66" name="Text 25"/>
+          <p:cNvPr id="67" name="Text 25"/>
           <p:cNvSpPr/>
           <p:nvPr/>
         </p:nvSpPr>
         <p:spPr>
           <a:xfrm>
             <a:off x="548640" y="658440"/>
-            <a:ext cx="11062080" cy="820800"/>
+            <a:ext cx="11061720" cy="820440"/>
           </a:xfrm>
           <a:prstGeom prst="rect">
             <a:avLst/>
@@ -13180,7 +13329,7 @@
               </a:rPr>
               <a:t>Why Realistic AI Datasets?</a:t>
             </a:r>
-            <a:endParaRPr b="0" lang="fr-FR" sz="3000" strike="noStrike" u="none">
+            <a:endParaRPr b="0" lang="en-US" sz="3000" strike="noStrike" u="none">
               <a:solidFill>
                 <a:srgbClr val="000000"/>
               </a:solidFill>
@@ -13193,14 +13342,14 @@
       </p:sp>
       <p:sp>
         <p:nvSpPr>
-          <p:cNvPr id="67" name="Text 26"/>
+          <p:cNvPr id="68" name="Text 26"/>
           <p:cNvSpPr/>
           <p:nvPr/>
         </p:nvSpPr>
         <p:spPr>
           <a:xfrm>
             <a:off x="11185920" y="6446520"/>
-            <a:ext cx="455040" cy="272160"/>
+            <a:ext cx="454680" cy="271800"/>
           </a:xfrm>
           <a:prstGeom prst="rect">
             <a:avLst/>
@@ -13241,7 +13390,7 @@
               </a:rPr>
               <a:t>2</a:t>
             </a:r>
-            <a:endParaRPr b="0" lang="fr-FR" sz="900" strike="noStrike" u="none">
+            <a:endParaRPr b="0" lang="en-US" sz="900" strike="noStrike" u="none">
               <a:solidFill>
                 <a:srgbClr val="000000"/>
               </a:solidFill>
@@ -13254,14 +13403,14 @@
       </p:sp>
       <p:sp>
         <p:nvSpPr>
-          <p:cNvPr id="68" name=""/>
+          <p:cNvPr id="69" name=""/>
           <p:cNvSpPr/>
           <p:nvPr/>
         </p:nvSpPr>
         <p:spPr>
           <a:xfrm>
             <a:off x="540000" y="1800000"/>
-            <a:ext cx="9475920" cy="3525840"/>
+            <a:ext cx="9475560" cy="3525840"/>
           </a:xfrm>
           <a:prstGeom prst="rect">
             <a:avLst/>
@@ -13318,7 +13467,7 @@
             <a:br>
               <a:rPr sz="2400"/>
             </a:br>
-            <a:endParaRPr b="0" lang="fr-FR" sz="2400" strike="noStrike" u="none">
+            <a:endParaRPr b="0" lang="en-US" sz="2400" strike="noStrike" u="none">
               <a:solidFill>
                 <a:srgbClr val="000000"/>
               </a:solidFill>
@@ -13366,7 +13515,7 @@
               </a:rPr>
               <a:t>: Reconstruct input parameters from measured data.</a:t>
             </a:r>
-            <a:endParaRPr b="0" lang="fr-FR" sz="2400" strike="noStrike" u="none">
+            <a:endParaRPr b="0" lang="en-US" sz="2400" strike="noStrike" u="none">
               <a:solidFill>
                 <a:srgbClr val="000000"/>
               </a:solidFill>
@@ -13428,7 +13577,7 @@
               </a:rPr>
               <a:t> </a:t>
             </a:r>
-            <a:endParaRPr b="0" lang="fr-FR" sz="2400" strike="noStrike" u="none">
+            <a:endParaRPr b="0" lang="en-US" sz="2400" strike="noStrike" u="none">
               <a:solidFill>
                 <a:srgbClr val="000000"/>
               </a:solidFill>
@@ -13463,7 +13612,7 @@
             <a:br>
               <a:rPr sz="2100"/>
             </a:br>
-            <a:endParaRPr b="0" lang="fr-FR" sz="2100" strike="noStrike" u="none">
+            <a:endParaRPr b="0" lang="en-US" sz="2100" strike="noStrike" u="none">
               <a:solidFill>
                 <a:srgbClr val="000000"/>
               </a:solidFill>
@@ -13500,7 +13649,7 @@
               </a:rPr>
               <a:t>Example: Predict sample composition from a scattering pattern.</a:t>
             </a:r>
-            <a:endParaRPr b="0" lang="fr-FR" sz="2400" strike="noStrike" u="none">
+            <a:endParaRPr b="0" lang="en-US" sz="2400" strike="noStrike" u="none">
               <a:solidFill>
                 <a:srgbClr val="000000"/>
               </a:solidFill>
@@ -13550,14 +13699,14 @@
       </p:grpSpPr>
       <p:sp>
         <p:nvSpPr>
-          <p:cNvPr id="69" name="Text 28"/>
+          <p:cNvPr id="70" name="Text 28"/>
           <p:cNvSpPr/>
           <p:nvPr/>
         </p:nvSpPr>
         <p:spPr>
           <a:xfrm>
             <a:off x="548640" y="384120"/>
-            <a:ext cx="9141840" cy="290520"/>
+            <a:ext cx="9141480" cy="290160"/>
           </a:xfrm>
           <a:prstGeom prst="rect">
             <a:avLst/>
@@ -13597,7 +13746,7 @@
               </a:rPr>
               <a:t>Realistic datasets</a:t>
             </a:r>
-            <a:endParaRPr b="0" lang="fr-FR" sz="1200" strike="noStrike" u="none">
+            <a:endParaRPr b="0" lang="en-US" sz="1200" strike="noStrike" u="none">
               <a:solidFill>
                 <a:srgbClr val="000000"/>
               </a:solidFill>
@@ -13610,14 +13759,14 @@
       </p:sp>
       <p:sp>
         <p:nvSpPr>
-          <p:cNvPr id="70" name="Text 29"/>
+          <p:cNvPr id="71" name="Text 29"/>
           <p:cNvSpPr/>
           <p:nvPr/>
         </p:nvSpPr>
         <p:spPr>
           <a:xfrm>
             <a:off x="548640" y="658440"/>
-            <a:ext cx="11062080" cy="820800"/>
+            <a:ext cx="11061720" cy="820440"/>
           </a:xfrm>
           <a:prstGeom prst="rect">
             <a:avLst/>
@@ -13663,7 +13812,7 @@
               </a:rPr>
               <a:t>Why Realistic AI Datasets?</a:t>
             </a:r>
-            <a:endParaRPr b="0" lang="fr-FR" sz="3000" strike="noStrike" u="none">
+            <a:endParaRPr b="0" lang="en-US" sz="3000" strike="noStrike" u="none">
               <a:solidFill>
                 <a:srgbClr val="000000"/>
               </a:solidFill>
@@ -13676,14 +13825,14 @@
       </p:sp>
       <p:sp>
         <p:nvSpPr>
-          <p:cNvPr id="71" name="Text 30"/>
+          <p:cNvPr id="72" name="Text 30"/>
           <p:cNvSpPr/>
           <p:nvPr/>
         </p:nvSpPr>
         <p:spPr>
           <a:xfrm>
             <a:off x="11185920" y="6446520"/>
-            <a:ext cx="455040" cy="272160"/>
+            <a:ext cx="454680" cy="271800"/>
           </a:xfrm>
           <a:prstGeom prst="rect">
             <a:avLst/>
@@ -13724,7 +13873,7 @@
               </a:rPr>
               <a:t>2</a:t>
             </a:r>
-            <a:endParaRPr b="0" lang="fr-FR" sz="900" strike="noStrike" u="none">
+            <a:endParaRPr b="0" lang="en-US" sz="900" strike="noStrike" u="none">
               <a:solidFill>
                 <a:srgbClr val="000000"/>
               </a:solidFill>
@@ -13737,14 +13886,14 @@
       </p:sp>
       <p:sp>
         <p:nvSpPr>
-          <p:cNvPr id="72" name=""/>
+          <p:cNvPr id="73" name=""/>
           <p:cNvSpPr/>
           <p:nvPr/>
         </p:nvSpPr>
         <p:spPr>
           <a:xfrm>
             <a:off x="540000" y="1800000"/>
-            <a:ext cx="10978560" cy="3160080"/>
+            <a:ext cx="10978200" cy="3160080"/>
           </a:xfrm>
           <a:prstGeom prst="rect">
             <a:avLst/>
@@ -13801,7 +13950,7 @@
             <a:br>
               <a:rPr sz="2400"/>
             </a:br>
-            <a:endParaRPr b="0" lang="fr-FR" sz="2400" strike="noStrike" u="none">
+            <a:endParaRPr b="0" lang="en-US" sz="2400" strike="noStrike" u="none">
               <a:solidFill>
                 <a:srgbClr val="000000"/>
               </a:solidFill>
@@ -13849,7 +13998,7 @@
               </a:rPr>
               <a:t>: Replace slow simulations with fast AI models.</a:t>
             </a:r>
-            <a:endParaRPr b="0" lang="fr-FR" sz="2400" strike="noStrike" u="none">
+            <a:endParaRPr b="0" lang="en-US" sz="2400" strike="noStrike" u="none">
               <a:solidFill>
                 <a:srgbClr val="000000"/>
               </a:solidFill>
@@ -13911,7 +14060,7 @@
               </a:rPr>
               <a:t> </a:t>
             </a:r>
-            <a:endParaRPr b="0" lang="fr-FR" sz="2400" strike="noStrike" u="none">
+            <a:endParaRPr b="0" lang="en-US" sz="2400" strike="noStrike" u="none">
               <a:solidFill>
                 <a:srgbClr val="000000"/>
               </a:solidFill>
@@ -13946,7 +14095,7 @@
             <a:br>
               <a:rPr sz="2100"/>
             </a:br>
-            <a:endParaRPr b="0" lang="fr-FR" sz="2100" strike="noStrike" u="none">
+            <a:endParaRPr b="0" lang="en-US" sz="2100" strike="noStrike" u="none">
               <a:solidFill>
                 <a:srgbClr val="000000"/>
               </a:solidFill>
@@ -13994,7 +14143,7 @@
               </a:rPr>
               <a:t>: Fast phase-space exploration.</a:t>
             </a:r>
-            <a:endParaRPr b="0" lang="fr-FR" sz="2400" strike="noStrike" u="none">
+            <a:endParaRPr b="0" lang="en-US" sz="2400" strike="noStrike" u="none">
               <a:solidFill>
                 <a:srgbClr val="000000"/>
               </a:solidFill>

</xml_diff>